<commit_message>
docs: atualiza slides de identificação e comparação dos métodos
- corrige o tempo de subida e a conclusão do slide de comparação (critério: acomodação)
- troca a figura do ajuste fino pela versão com zoom
- adiciona as fórmulas de Smith e Sundaresan e o slide 'Por que Smith?'
</commit_message>
<xml_diff>
--- a/Slides_Projeto_C13_1.pptx
+++ b/Slides_Projeto_C13_1.pptx
@@ -2,20 +2,20 @@
 <file path=ppt/presentation.xml><?xml version="1.0" encoding="utf-8"?>
 <p:presentation xmlns:a="http://schemas.openxmlformats.org/drawingml/2006/main" xmlns:r="http://schemas.openxmlformats.org/officeDocument/2006/relationships" xmlns:p="http://schemas.openxmlformats.org/presentationml/2006/main" saveSubsetFonts="1" autoCompressPictures="0">
   <p:sldMasterIdLst>
-    <p:sldMasterId id="2147483660" r:id="rId1"/>
+    <p:sldMasterId id="2147483660" r:id="rId4"/>
   </p:sldMasterIdLst>
   <p:sldIdLst>
-    <p:sldId id="263" r:id="rId2"/>
-    <p:sldId id="261" r:id="rId3"/>
-    <p:sldId id="260" r:id="rId4"/>
-    <p:sldId id="265" r:id="rId5"/>
-    <p:sldId id="256" r:id="rId6"/>
-    <p:sldId id="266" r:id="rId7"/>
-    <p:sldId id="258" r:id="rId8"/>
-    <p:sldId id="267" r:id="rId9"/>
-    <p:sldId id="264" r:id="rId10"/>
-    <p:sldId id="257" r:id="rId11"/>
-    <p:sldId id="259" r:id="rId12"/>
+    <p:sldId id="263" r:id="rId5"/>
+    <p:sldId id="261" r:id="rId6"/>
+    <p:sldId id="260" r:id="rId7"/>
+    <p:sldId id="265" r:id="rId8"/>
+    <p:sldId id="256" r:id="rId9"/>
+    <p:sldId id="266" r:id="rId10"/>
+    <p:sldId id="258" r:id="rId11"/>
+    <p:sldId id="267" r:id="rId12"/>
+    <p:sldId id="264" r:id="rId13"/>
+    <p:sldId id="257" r:id="rId14"/>
+    <p:sldId id="259" r:id="rId15"/>
   </p:sldIdLst>
   <p:sldSz cx="12192000" cy="6858000"/>
   <p:notesSz cx="6858000" cy="9144000"/>
@@ -136,7 +136,7 @@
 <file path=ppt/revisionInfo.xml><?xml version="1.0" encoding="utf-8"?>
 <p1510:revInfo xmlns:a="http://schemas.openxmlformats.org/drawingml/2006/main" xmlns:r="http://schemas.openxmlformats.org/officeDocument/2006/relationships" xmlns:p1510="http://schemas.microsoft.com/office/powerpoint/2015/10/main">
   <p1510:revLst>
-    <p1510:client id="{EC7B7C88-1FBC-49CD-8864-839D3818F98A}" v="323" dt="2026-10-13T00:53:13.478"/>
+    <p1510:client id="{43786F9E-9D52-43D4-8441-F885A8DF3474}" v="4" dt="2026-10-13T01:33:37.481"/>
   </p1510:revLst>
 </p1510:revInfo>
 </file>
@@ -145,483 +145,80 @@
 <pc:chgInfo xmlns:a="http://schemas.openxmlformats.org/drawingml/2006/main" xmlns:r="http://schemas.openxmlformats.org/officeDocument/2006/relationships" xmlns:ac="http://schemas.microsoft.com/office/drawing/2013/main/command" xmlns:pc="http://schemas.microsoft.com/office/powerpoint/2013/main/command">
   <pc:docChgLst>
     <pc:chgData name="Maria Rita" userId="6072d1a607af3438" providerId="LiveId" clId="{E2C0015B-DB19-4E69-98EF-8810F8F8B916}"/>
-    <pc:docChg chg="undo custSel addSld delSld modSld sldOrd">
-      <pc:chgData name="Maria Rita" userId="6072d1a607af3438" providerId="LiveId" clId="{E2C0015B-DB19-4E69-98EF-8810F8F8B916}" dt="2026-10-13T00:56:44.617" v="1629" actId="115"/>
+    <pc:docChg chg="undo custSel modSld">
+      <pc:chgData name="Maria Rita" userId="6072d1a607af3438" providerId="LiveId" clId="{E2C0015B-DB19-4E69-98EF-8810F8F8B916}" dt="2026-10-13T01:35:58.595" v="41" actId="1076"/>
       <pc:docMkLst>
         <pc:docMk/>
       </pc:docMkLst>
-      <pc:sldChg chg="addSp delSp modSp mod ord">
-        <pc:chgData name="Maria Rita" userId="6072d1a607af3438" providerId="LiveId" clId="{E2C0015B-DB19-4E69-98EF-8810F8F8B916}" dt="2026-10-13T00:54:31.540" v="1627" actId="1076"/>
+      <pc:sldChg chg="addSp delSp modSp mod">
+        <pc:chgData name="Maria Rita" userId="6072d1a607af3438" providerId="LiveId" clId="{E2C0015B-DB19-4E69-98EF-8810F8F8B916}" dt="2026-10-13T01:35:58.595" v="41" actId="1076"/>
         <pc:sldMkLst>
           <pc:docMk/>
-          <pc:sldMk cId="0" sldId="256"/>
+          <pc:sldMk cId="0" sldId="257"/>
         </pc:sldMkLst>
-        <pc:spChg chg="mod">
-          <ac:chgData name="Maria Rita" userId="6072d1a607af3438" providerId="LiveId" clId="{E2C0015B-DB19-4E69-98EF-8810F8F8B916}" dt="2026-10-13T00:51:06.990" v="1546" actId="34135"/>
-          <ac:spMkLst>
+        <pc:picChg chg="add mod">
+          <ac:chgData name="Maria Rita" userId="6072d1a607af3438" providerId="LiveId" clId="{E2C0015B-DB19-4E69-98EF-8810F8F8B916}" dt="2026-10-13T01:35:58.595" v="41" actId="1076"/>
+          <ac:picMkLst>
             <pc:docMk/>
-            <pc:sldMk cId="0" sldId="256"/>
-            <ac:spMk id="2" creationId="{00000000-0000-0000-0000-000000000000}"/>
-          </ac:spMkLst>
-        </pc:spChg>
-        <pc:spChg chg="mod">
-          <ac:chgData name="Maria Rita" userId="6072d1a607af3438" providerId="LiveId" clId="{E2C0015B-DB19-4E69-98EF-8810F8F8B916}" dt="2026-10-13T00:48:37.743" v="1439" actId="164"/>
-          <ac:spMkLst>
+            <pc:sldMk cId="0" sldId="257"/>
+            <ac:picMk id="18" creationId="{BC016C3C-5768-3348-99B1-97BCA122B34F}"/>
+          </ac:picMkLst>
+        </pc:picChg>
+        <pc:picChg chg="del">
+          <ac:chgData name="Maria Rita" userId="6072d1a607af3438" providerId="LiveId" clId="{E2C0015B-DB19-4E69-98EF-8810F8F8B916}" dt="2026-10-13T01:34:21.062" v="34" actId="478"/>
+          <ac:picMkLst>
             <pc:docMk/>
-            <pc:sldMk cId="0" sldId="256"/>
-            <ac:spMk id="6" creationId="{00000000-0000-0000-0000-000000000000}"/>
-          </ac:spMkLst>
-        </pc:spChg>
-        <pc:spChg chg="mod">
-          <ac:chgData name="Maria Rita" userId="6072d1a607af3438" providerId="LiveId" clId="{E2C0015B-DB19-4E69-98EF-8810F8F8B916}" dt="2026-10-13T00:53:54.215" v="1623" actId="403"/>
-          <ac:spMkLst>
-            <pc:docMk/>
-            <pc:sldMk cId="0" sldId="256"/>
-            <ac:spMk id="7" creationId="{00000000-0000-0000-0000-000000000000}"/>
-          </ac:spMkLst>
-        </pc:spChg>
-        <pc:spChg chg="mod">
-          <ac:chgData name="Maria Rita" userId="6072d1a607af3438" providerId="LiveId" clId="{E2C0015B-DB19-4E69-98EF-8810F8F8B916}" dt="2026-10-13T00:53:43.562" v="1619" actId="113"/>
-          <ac:spMkLst>
-            <pc:docMk/>
-            <pc:sldMk cId="0" sldId="256"/>
-            <ac:spMk id="8" creationId="{00000000-0000-0000-0000-000000000000}"/>
-          </ac:spMkLst>
-        </pc:spChg>
-        <pc:spChg chg="mod">
-          <ac:chgData name="Maria Rita" userId="6072d1a607af3438" providerId="LiveId" clId="{E2C0015B-DB19-4E69-98EF-8810F8F8B916}" dt="2026-10-13T00:53:13.478" v="1610" actId="164"/>
-          <ac:spMkLst>
-            <pc:docMk/>
-            <pc:sldMk cId="0" sldId="256"/>
-            <ac:spMk id="9" creationId="{00000000-0000-0000-0000-000000000000}"/>
-          </ac:spMkLst>
-        </pc:spChg>
-        <pc:spChg chg="del">
-          <ac:chgData name="Maria Rita" userId="6072d1a607af3438" providerId="LiveId" clId="{E2C0015B-DB19-4E69-98EF-8810F8F8B916}" dt="2026-10-13T00:49:05.941" v="1443" actId="478"/>
-          <ac:spMkLst>
-            <pc:docMk/>
-            <pc:sldMk cId="0" sldId="256"/>
-            <ac:spMk id="10" creationId="{00000000-0000-0000-0000-000000000000}"/>
-          </ac:spMkLst>
-        </pc:spChg>
-        <pc:spChg chg="mod">
-          <ac:chgData name="Maria Rita" userId="6072d1a607af3438" providerId="LiveId" clId="{E2C0015B-DB19-4E69-98EF-8810F8F8B916}" dt="2026-10-13T00:53:13.478" v="1610" actId="164"/>
-          <ac:spMkLst>
-            <pc:docMk/>
-            <pc:sldMk cId="0" sldId="256"/>
-            <ac:spMk id="11" creationId="{00000000-0000-0000-0000-000000000000}"/>
-          </ac:spMkLst>
-        </pc:spChg>
-        <pc:spChg chg="add mod">
-          <ac:chgData name="Maria Rita" userId="6072d1a607af3438" providerId="LiveId" clId="{E2C0015B-DB19-4E69-98EF-8810F8F8B916}" dt="2026-10-13T00:52:52.994" v="1606" actId="164"/>
-          <ac:spMkLst>
-            <pc:docMk/>
-            <pc:sldMk cId="0" sldId="256"/>
-            <ac:spMk id="12" creationId="{260A5732-61CA-E2D1-CCB0-A380A53FD303}"/>
-          </ac:spMkLst>
-        </pc:spChg>
-        <pc:spChg chg="add del">
-          <ac:chgData name="Maria Rita" userId="6072d1a607af3438" providerId="LiveId" clId="{E2C0015B-DB19-4E69-98EF-8810F8F8B916}" dt="2026-10-13T00:51:28.513" v="1553" actId="22"/>
-          <ac:spMkLst>
-            <pc:docMk/>
-            <pc:sldMk cId="0" sldId="256"/>
-            <ac:spMk id="14" creationId="{D68C9ACA-9074-63D2-3A2D-21F232212CFF}"/>
-          </ac:spMkLst>
-        </pc:spChg>
-        <pc:spChg chg="add mod">
-          <ac:chgData name="Maria Rita" userId="6072d1a607af3438" providerId="LiveId" clId="{E2C0015B-DB19-4E69-98EF-8810F8F8B916}" dt="2026-10-13T00:52:52.994" v="1606" actId="164"/>
-          <ac:spMkLst>
-            <pc:docMk/>
-            <pc:sldMk cId="0" sldId="256"/>
-            <ac:spMk id="16" creationId="{021F7662-C79F-175F-064C-1B5CE20D93BF}"/>
-          </ac:spMkLst>
-        </pc:spChg>
-        <pc:grpChg chg="add mod">
-          <ac:chgData name="Maria Rita" userId="6072d1a607af3438" providerId="LiveId" clId="{E2C0015B-DB19-4E69-98EF-8810F8F8B916}" dt="2026-10-13T00:54:31.540" v="1627" actId="1076"/>
-          <ac:grpSpMkLst>
-            <pc:docMk/>
-            <pc:sldMk cId="0" sldId="256"/>
-            <ac:grpSpMk id="4" creationId="{1D913A5F-FDEC-8607-ADE8-A9127271F4D0}"/>
-          </ac:grpSpMkLst>
-        </pc:grpChg>
-        <pc:grpChg chg="add mod">
-          <ac:chgData name="Maria Rita" userId="6072d1a607af3438" providerId="LiveId" clId="{E2C0015B-DB19-4E69-98EF-8810F8F8B916}" dt="2026-10-13T00:53:23.160" v="1612" actId="1076"/>
-          <ac:grpSpMkLst>
-            <pc:docMk/>
-            <pc:sldMk cId="0" sldId="256"/>
-            <ac:grpSpMk id="17" creationId="{D00D8935-475A-EDD4-8E76-A5AF334EDE12}"/>
-          </ac:grpSpMkLst>
-        </pc:grpChg>
-        <pc:grpChg chg="add mod">
-          <ac:chgData name="Maria Rita" userId="6072d1a607af3438" providerId="LiveId" clId="{E2C0015B-DB19-4E69-98EF-8810F8F8B916}" dt="2026-10-13T00:54:14.310" v="1626" actId="1076"/>
-          <ac:grpSpMkLst>
-            <pc:docMk/>
-            <pc:sldMk cId="0" sldId="256"/>
-            <ac:grpSpMk id="18" creationId="{2FF8D55D-2B89-0BDC-B855-E461198775C1}"/>
-          </ac:grpSpMkLst>
-        </pc:grpChg>
+            <pc:sldMk cId="0" sldId="257"/>
+            <ac:picMk id="25" creationId="{8A86A204-936B-4CEA-B2D3-D6EFCE09E405}"/>
+          </ac:picMkLst>
+        </pc:picChg>
       </pc:sldChg>
-      <pc:sldChg chg="modSp mod">
-        <pc:chgData name="Maria Rita" userId="6072d1a607af3438" providerId="LiveId" clId="{E2C0015B-DB19-4E69-98EF-8810F8F8B916}" dt="2026-10-13T00:56:44.617" v="1629" actId="115"/>
+      <pc:sldChg chg="addSp modSp mod">
+        <pc:chgData name="Maria Rita" userId="6072d1a607af3438" providerId="LiveId" clId="{E2C0015B-DB19-4E69-98EF-8810F8F8B916}" dt="2026-10-13T01:33:59.826" v="33" actId="2711"/>
         <pc:sldMkLst>
           <pc:docMk/>
           <pc:sldMk cId="0" sldId="259"/>
         </pc:sldMkLst>
         <pc:spChg chg="mod">
-          <ac:chgData name="Maria Rita" userId="6072d1a607af3438" providerId="LiveId" clId="{E2C0015B-DB19-4E69-98EF-8810F8F8B916}" dt="2026-10-13T00:56:44.617" v="1629" actId="115"/>
+          <ac:chgData name="Maria Rita" userId="6072d1a607af3438" providerId="LiveId" clId="{E2C0015B-DB19-4E69-98EF-8810F8F8B916}" dt="2026-10-13T01:32:04.679" v="9" actId="113"/>
           <ac:spMkLst>
             <pc:docMk/>
             <pc:sldMk cId="0" sldId="259"/>
-            <ac:spMk id="2" creationId="{00000000-0000-0000-0000-000000000000}"/>
-          </ac:spMkLst>
-        </pc:spChg>
-      </pc:sldChg>
-      <pc:sldChg chg="addSp delSp modSp mod">
-        <pc:chgData name="Maria Rita" userId="6072d1a607af3438" providerId="LiveId" clId="{E2C0015B-DB19-4E69-98EF-8810F8F8B916}" dt="2026-10-13T00:44:22.706" v="1242" actId="1076"/>
-        <pc:sldMkLst>
-          <pc:docMk/>
-          <pc:sldMk cId="0" sldId="260"/>
-        </pc:sldMkLst>
-        <pc:spChg chg="mod">
-          <ac:chgData name="Maria Rita" userId="6072d1a607af3438" providerId="LiveId" clId="{E2C0015B-DB19-4E69-98EF-8810F8F8B916}" dt="2026-10-12T23:56:23.385" v="24" actId="20577"/>
-          <ac:spMkLst>
-            <pc:docMk/>
-            <pc:sldMk cId="0" sldId="260"/>
-            <ac:spMk id="2" creationId="{00000000-0000-0000-0000-000000000000}"/>
+            <ac:spMk id="9" creationId="{00000000-0000-0000-0000-000000000000}"/>
           </ac:spMkLst>
         </pc:spChg>
         <pc:spChg chg="mod">
-          <ac:chgData name="Maria Rita" userId="6072d1a607af3438" providerId="LiveId" clId="{E2C0015B-DB19-4E69-98EF-8810F8F8B916}" dt="2026-10-13T00:08:33.915" v="511" actId="164"/>
+          <ac:chgData name="Maria Rita" userId="6072d1a607af3438" providerId="LiveId" clId="{E2C0015B-DB19-4E69-98EF-8810F8F8B916}" dt="2026-10-13T01:32:12.612" v="19" actId="20577"/>
           <ac:spMkLst>
             <pc:docMk/>
-            <pc:sldMk cId="0" sldId="260"/>
-            <ac:spMk id="6" creationId="{00000000-0000-0000-0000-000000000000}"/>
-          </ac:spMkLst>
-        </pc:spChg>
-        <pc:spChg chg="del">
-          <ac:chgData name="Maria Rita" userId="6072d1a607af3438" providerId="LiveId" clId="{E2C0015B-DB19-4E69-98EF-8810F8F8B916}" dt="2026-10-12T23:56:52.367" v="25" actId="478"/>
-          <ac:spMkLst>
-            <pc:docMk/>
-            <pc:sldMk cId="0" sldId="260"/>
-            <ac:spMk id="7" creationId="{00000000-0000-0000-0000-000000000000}"/>
-          </ac:spMkLst>
-        </pc:spChg>
-        <pc:spChg chg="mod ord">
-          <ac:chgData name="Maria Rita" userId="6072d1a607af3438" providerId="LiveId" clId="{E2C0015B-DB19-4E69-98EF-8810F8F8B916}" dt="2026-10-13T00:09:47.659" v="520" actId="166"/>
-          <ac:spMkLst>
-            <pc:docMk/>
-            <pc:sldMk cId="0" sldId="260"/>
-            <ac:spMk id="8" creationId="{00000000-0000-0000-0000-000000000000}"/>
-          </ac:spMkLst>
-        </pc:spChg>
-        <pc:spChg chg="del mod">
-          <ac:chgData name="Maria Rita" userId="6072d1a607af3438" providerId="LiveId" clId="{E2C0015B-DB19-4E69-98EF-8810F8F8B916}" dt="2026-10-13T00:07:23.080" v="498" actId="478"/>
-          <ac:spMkLst>
-            <pc:docMk/>
-            <pc:sldMk cId="0" sldId="260"/>
-            <ac:spMk id="9" creationId="{00000000-0000-0000-0000-000000000000}"/>
-          </ac:spMkLst>
-        </pc:spChg>
-        <pc:spChg chg="del mod">
-          <ac:chgData name="Maria Rita" userId="6072d1a607af3438" providerId="LiveId" clId="{E2C0015B-DB19-4E69-98EF-8810F8F8B916}" dt="2026-10-13T00:07:25.773" v="503" actId="478"/>
-          <ac:spMkLst>
-            <pc:docMk/>
-            <pc:sldMk cId="0" sldId="260"/>
-            <ac:spMk id="10" creationId="{00000000-0000-0000-0000-000000000000}"/>
-          </ac:spMkLst>
-        </pc:spChg>
-        <pc:spChg chg="del mod">
-          <ac:chgData name="Maria Rita" userId="6072d1a607af3438" providerId="LiveId" clId="{E2C0015B-DB19-4E69-98EF-8810F8F8B916}" dt="2026-10-13T00:07:23.080" v="500"/>
-          <ac:spMkLst>
-            <pc:docMk/>
-            <pc:sldMk cId="0" sldId="260"/>
-            <ac:spMk id="11" creationId="{00000000-0000-0000-0000-000000000000}"/>
-          </ac:spMkLst>
-        </pc:spChg>
-        <pc:spChg chg="del mod">
-          <ac:chgData name="Maria Rita" userId="6072d1a607af3438" providerId="LiveId" clId="{E2C0015B-DB19-4E69-98EF-8810F8F8B916}" dt="2026-10-13T00:07:07.303" v="495" actId="21"/>
-          <ac:spMkLst>
-            <pc:docMk/>
-            <pc:sldMk cId="0" sldId="260"/>
+            <pc:sldMk cId="0" sldId="259"/>
             <ac:spMk id="12" creationId="{00000000-0000-0000-0000-000000000000}"/>
           </ac:spMkLst>
         </pc:spChg>
-        <pc:spChg chg="add del mod">
-          <ac:chgData name="Maria Rita" userId="6072d1a607af3438" providerId="LiveId" clId="{E2C0015B-DB19-4E69-98EF-8810F8F8B916}" dt="2026-10-13T00:06:49.600" v="494" actId="478"/>
+        <pc:spChg chg="mod">
+          <ac:chgData name="Maria Rita" userId="6072d1a607af3438" providerId="LiveId" clId="{E2C0015B-DB19-4E69-98EF-8810F8F8B916}" dt="2026-10-13T01:33:59.826" v="33" actId="2711"/>
           <ac:spMkLst>
             <pc:docMk/>
-            <pc:sldMk cId="0" sldId="260"/>
-            <ac:spMk id="13" creationId="{00000000-0000-0000-0000-000000000000}"/>
-          </ac:spMkLst>
-        </pc:spChg>
-        <pc:spChg chg="del">
-          <ac:chgData name="Maria Rita" userId="6072d1a607af3438" providerId="LiveId" clId="{E2C0015B-DB19-4E69-98EF-8810F8F8B916}" dt="2026-10-13T00:07:26.850" v="504" actId="478"/>
-          <ac:spMkLst>
-            <pc:docMk/>
-            <pc:sldMk cId="0" sldId="260"/>
+            <pc:sldMk cId="0" sldId="259"/>
             <ac:spMk id="15" creationId="{00000000-0000-0000-0000-000000000000}"/>
           </ac:spMkLst>
         </pc:spChg>
-        <pc:spChg chg="del">
-          <ac:chgData name="Maria Rita" userId="6072d1a607af3438" providerId="LiveId" clId="{E2C0015B-DB19-4E69-98EF-8810F8F8B916}" dt="2026-10-13T00:06:49.600" v="494" actId="478"/>
-          <ac:spMkLst>
+        <pc:graphicFrameChg chg="add mod">
+          <ac:chgData name="Maria Rita" userId="6072d1a607af3438" providerId="LiveId" clId="{E2C0015B-DB19-4E69-98EF-8810F8F8B916}" dt="2026-10-13T01:31:50.599" v="3"/>
+          <ac:graphicFrameMkLst>
             <pc:docMk/>
-            <pc:sldMk cId="0" sldId="260"/>
-            <ac:spMk id="16" creationId="{00000000-0000-0000-0000-000000000000}"/>
-          </ac:spMkLst>
-        </pc:spChg>
-        <pc:spChg chg="del mod">
-          <ac:chgData name="Maria Rita" userId="6072d1a607af3438" providerId="LiveId" clId="{E2C0015B-DB19-4E69-98EF-8810F8F8B916}" dt="2026-10-13T00:07:30.876" v="507" actId="478"/>
-          <ac:spMkLst>
-            <pc:docMk/>
-            <pc:sldMk cId="0" sldId="260"/>
-            <ac:spMk id="17" creationId="{00000000-0000-0000-0000-000000000000}"/>
-          </ac:spMkLst>
-        </pc:spChg>
-        <pc:spChg chg="del mod">
-          <ac:chgData name="Maria Rita" userId="6072d1a607af3438" providerId="LiveId" clId="{E2C0015B-DB19-4E69-98EF-8810F8F8B916}" dt="2026-10-13T00:07:32.624" v="509" actId="478"/>
-          <ac:spMkLst>
-            <pc:docMk/>
-            <pc:sldMk cId="0" sldId="260"/>
-            <ac:spMk id="18" creationId="{00000000-0000-0000-0000-000000000000}"/>
-          </ac:spMkLst>
-        </pc:spChg>
-        <pc:grpChg chg="add mod">
-          <ac:chgData name="Maria Rita" userId="6072d1a607af3438" providerId="LiveId" clId="{E2C0015B-DB19-4E69-98EF-8810F8F8B916}" dt="2026-10-13T00:44:22.706" v="1242" actId="1076"/>
-          <ac:grpSpMkLst>
-            <pc:docMk/>
-            <pc:sldMk cId="0" sldId="260"/>
-            <ac:grpSpMk id="4" creationId="{4BCFBF66-A8E1-A508-75BF-D6504E95DE62}"/>
-          </ac:grpSpMkLst>
-        </pc:grpChg>
-        <pc:picChg chg="add mod ord">
-          <ac:chgData name="Maria Rita" userId="6072d1a607af3438" providerId="LiveId" clId="{E2C0015B-DB19-4E69-98EF-8810F8F8B916}" dt="2026-10-13T00:44:16.521" v="1241" actId="1076"/>
+            <pc:sldMk cId="0" sldId="259"/>
+            <ac:graphicFrameMk id="5" creationId="{3147F48C-EF1D-8D0E-E811-9394F0AA358E}"/>
+          </ac:graphicFrameMkLst>
+        </pc:graphicFrameChg>
+        <pc:picChg chg="mod">
+          <ac:chgData name="Maria Rita" userId="6072d1a607af3438" providerId="LiveId" clId="{E2C0015B-DB19-4E69-98EF-8810F8F8B916}" dt="2026-10-13T01:30:17.850" v="1" actId="1076"/>
           <ac:picMkLst>
             <pc:docMk/>
-            <pc:sldMk cId="0" sldId="260"/>
-            <ac:picMk id="14" creationId="{70400D51-F05B-85CB-3685-78A1AF503B3E}"/>
+            <pc:sldMk cId="0" sldId="259"/>
+            <ac:picMk id="16" creationId="{00000000-0000-0000-0000-000000000000}"/>
           </ac:picMkLst>
         </pc:picChg>
-      </pc:sldChg>
-      <pc:sldChg chg="addSp delSp modSp add mod">
-        <pc:chgData name="Maria Rita" userId="6072d1a607af3438" providerId="LiveId" clId="{E2C0015B-DB19-4E69-98EF-8810F8F8B916}" dt="2026-10-13T00:42:20.238" v="1237" actId="1076"/>
-        <pc:sldMkLst>
-          <pc:docMk/>
-          <pc:sldMk cId="760060564" sldId="265"/>
-        </pc:sldMkLst>
-        <pc:spChg chg="mod">
-          <ac:chgData name="Maria Rita" userId="6072d1a607af3438" providerId="LiveId" clId="{E2C0015B-DB19-4E69-98EF-8810F8F8B916}" dt="2026-10-13T00:25:57.668" v="953" actId="34135"/>
-          <ac:spMkLst>
-            <pc:docMk/>
-            <pc:sldMk cId="760060564" sldId="265"/>
-            <ac:spMk id="2" creationId="{C5094305-8C85-A818-FDAE-DCBB6710C907}"/>
-          </ac:spMkLst>
-        </pc:spChg>
-        <pc:spChg chg="mod">
-          <ac:chgData name="Maria Rita" userId="6072d1a607af3438" providerId="LiveId" clId="{E2C0015B-DB19-4E69-98EF-8810F8F8B916}" dt="2026-10-13T00:29:37.779" v="1039" actId="20577"/>
-          <ac:spMkLst>
-            <pc:docMk/>
-            <pc:sldMk cId="760060564" sldId="265"/>
-            <ac:spMk id="6" creationId="{E85EB215-936F-DC1C-FD87-2D90116A9623}"/>
-          </ac:spMkLst>
-        </pc:spChg>
-        <pc:spChg chg="del">
-          <ac:chgData name="Maria Rita" userId="6072d1a607af3438" providerId="LiveId" clId="{E2C0015B-DB19-4E69-98EF-8810F8F8B916}" dt="2026-10-13T00:17:42.310" v="769" actId="478"/>
-          <ac:spMkLst>
-            <pc:docMk/>
-            <pc:sldMk cId="760060564" sldId="265"/>
-            <ac:spMk id="7" creationId="{283F7B1E-AD22-42E4-6979-9F9263827AF1}"/>
-          </ac:spMkLst>
-        </pc:spChg>
-        <pc:spChg chg="mod">
-          <ac:chgData name="Maria Rita" userId="6072d1a607af3438" providerId="LiveId" clId="{E2C0015B-DB19-4E69-98EF-8810F8F8B916}" dt="2026-10-13T00:29:38.299" v="1040" actId="5793"/>
-          <ac:spMkLst>
-            <pc:docMk/>
-            <pc:sldMk cId="760060564" sldId="265"/>
-            <ac:spMk id="8" creationId="{4494D955-79B7-5615-A3A5-D4585D3809E1}"/>
-          </ac:spMkLst>
-        </pc:spChg>
-        <pc:spChg chg="mod">
-          <ac:chgData name="Maria Rita" userId="6072d1a607af3438" providerId="LiveId" clId="{E2C0015B-DB19-4E69-98EF-8810F8F8B916}" dt="2026-10-13T00:39:30.610" v="1200" actId="1076"/>
-          <ac:spMkLst>
-            <pc:docMk/>
-            <pc:sldMk cId="760060564" sldId="265"/>
-            <ac:spMk id="9" creationId="{C4357678-8523-53F2-615B-CC28AC90D6EA}"/>
-          </ac:spMkLst>
-        </pc:spChg>
-        <pc:spChg chg="del mod">
-          <ac:chgData name="Maria Rita" userId="6072d1a607af3438" providerId="LiveId" clId="{E2C0015B-DB19-4E69-98EF-8810F8F8B916}" dt="2026-10-13T00:25:31.758" v="941" actId="478"/>
-          <ac:spMkLst>
-            <pc:docMk/>
-            <pc:sldMk cId="760060564" sldId="265"/>
-            <ac:spMk id="10" creationId="{40865BC2-0E19-7E74-5877-B500A7662FE1}"/>
-          </ac:spMkLst>
-        </pc:spChg>
-        <pc:spChg chg="mod">
-          <ac:chgData name="Maria Rita" userId="6072d1a607af3438" providerId="LiveId" clId="{E2C0015B-DB19-4E69-98EF-8810F8F8B916}" dt="2026-10-13T00:26:07.891" v="957" actId="164"/>
-          <ac:spMkLst>
-            <pc:docMk/>
-            <pc:sldMk cId="760060564" sldId="265"/>
-            <ac:spMk id="11" creationId="{E937F416-09A8-258F-15CC-AE1577693AAB}"/>
-          </ac:spMkLst>
-        </pc:spChg>
-        <pc:spChg chg="mod">
-          <ac:chgData name="Maria Rita" userId="6072d1a607af3438" providerId="LiveId" clId="{E2C0015B-DB19-4E69-98EF-8810F8F8B916}" dt="2026-10-13T00:41:57.715" v="1232" actId="1076"/>
-          <ac:spMkLst>
-            <pc:docMk/>
-            <pc:sldMk cId="760060564" sldId="265"/>
-            <ac:spMk id="12" creationId="{EEBD569C-2811-DABA-E662-7366F6547F02}"/>
-          </ac:spMkLst>
-        </pc:spChg>
-        <pc:spChg chg="add del mod">
-          <ac:chgData name="Maria Rita" userId="6072d1a607af3438" providerId="LiveId" clId="{E2C0015B-DB19-4E69-98EF-8810F8F8B916}" dt="2026-10-13T00:24:46.470" v="936" actId="164"/>
-          <ac:spMkLst>
-            <pc:docMk/>
-            <pc:sldMk cId="760060564" sldId="265"/>
-            <ac:spMk id="13" creationId="{395411BB-51E0-4998-1D76-1F2B06CF3F66}"/>
-          </ac:spMkLst>
-        </pc:spChg>
-        <pc:spChg chg="add del mod">
-          <ac:chgData name="Maria Rita" userId="6072d1a607af3438" providerId="LiveId" clId="{E2C0015B-DB19-4E69-98EF-8810F8F8B916}" dt="2026-10-13T00:26:01.398" v="956"/>
-          <ac:spMkLst>
-            <pc:docMk/>
-            <pc:sldMk cId="760060564" sldId="265"/>
-            <ac:spMk id="14" creationId="{EFB0BF8F-E708-F63B-8F0C-0EB2DFF02224}"/>
-          </ac:spMkLst>
-        </pc:spChg>
-        <pc:spChg chg="del">
-          <ac:chgData name="Maria Rita" userId="6072d1a607af3438" providerId="LiveId" clId="{E2C0015B-DB19-4E69-98EF-8810F8F8B916}" dt="2026-10-13T00:25:35.794" v="943" actId="478"/>
-          <ac:spMkLst>
-            <pc:docMk/>
-            <pc:sldMk cId="760060564" sldId="265"/>
-            <ac:spMk id="15" creationId="{B530E820-5410-0C34-3BC2-38483F119740}"/>
-          </ac:spMkLst>
-        </pc:spChg>
-        <pc:spChg chg="del">
-          <ac:chgData name="Maria Rita" userId="6072d1a607af3438" providerId="LiveId" clId="{E2C0015B-DB19-4E69-98EF-8810F8F8B916}" dt="2026-10-13T00:25:34.780" v="942" actId="478"/>
-          <ac:spMkLst>
-            <pc:docMk/>
-            <pc:sldMk cId="760060564" sldId="265"/>
-            <ac:spMk id="16" creationId="{946D7491-AF5B-D8B0-5478-61ADF76020B3}"/>
-          </ac:spMkLst>
-        </pc:spChg>
-        <pc:spChg chg="add del mod">
-          <ac:chgData name="Maria Rita" userId="6072d1a607af3438" providerId="LiveId" clId="{E2C0015B-DB19-4E69-98EF-8810F8F8B916}" dt="2026-10-13T00:25:48.722" v="950" actId="478"/>
-          <ac:spMkLst>
-            <pc:docMk/>
-            <pc:sldMk cId="760060564" sldId="265"/>
-            <ac:spMk id="17" creationId="{A294C6D4-8803-99E7-7002-F621CB659D9A}"/>
-          </ac:spMkLst>
-        </pc:spChg>
-        <pc:spChg chg="del">
-          <ac:chgData name="Maria Rita" userId="6072d1a607af3438" providerId="LiveId" clId="{E2C0015B-DB19-4E69-98EF-8810F8F8B916}" dt="2026-10-13T00:40:13.432" v="1209" actId="478"/>
-          <ac:spMkLst>
-            <pc:docMk/>
-            <pc:sldMk cId="760060564" sldId="265"/>
-            <ac:spMk id="18" creationId="{87AC288C-263F-14EB-8B23-1EA692A8DF36}"/>
-          </ac:spMkLst>
-        </pc:spChg>
-        <pc:spChg chg="add del mod">
-          <ac:chgData name="Maria Rita" userId="6072d1a607af3438" providerId="LiveId" clId="{E2C0015B-DB19-4E69-98EF-8810F8F8B916}" dt="2026-10-13T00:39:25.376" v="1198" actId="478"/>
-          <ac:spMkLst>
-            <pc:docMk/>
-            <pc:sldMk cId="760060564" sldId="265"/>
-            <ac:spMk id="20" creationId="{AD7A9453-F202-5FA6-0DA6-CFEC42004057}"/>
-          </ac:spMkLst>
-        </pc:spChg>
-        <pc:spChg chg="mod">
-          <ac:chgData name="Maria Rita" userId="6072d1a607af3438" providerId="LiveId" clId="{E2C0015B-DB19-4E69-98EF-8810F8F8B916}" dt="2026-10-13T00:31:27.531" v="1067" actId="164"/>
-          <ac:spMkLst>
-            <pc:docMk/>
-            <pc:sldMk cId="760060564" sldId="265"/>
-            <ac:spMk id="22" creationId="{1E937703-FA27-B113-C8B5-57A0888F8FA1}"/>
-          </ac:spMkLst>
-        </pc:spChg>
-        <pc:spChg chg="mod">
-          <ac:chgData name="Maria Rita" userId="6072d1a607af3438" providerId="LiveId" clId="{E2C0015B-DB19-4E69-98EF-8810F8F8B916}" dt="2026-10-13T00:31:27.531" v="1067" actId="164"/>
-          <ac:spMkLst>
-            <pc:docMk/>
-            <pc:sldMk cId="760060564" sldId="265"/>
-            <ac:spMk id="23" creationId="{CE73B1F5-A6E9-29AE-AED1-B906A2DB7E26}"/>
-          </ac:spMkLst>
-        </pc:spChg>
-        <pc:grpChg chg="add mod">
-          <ac:chgData name="Maria Rita" userId="6072d1a607af3438" providerId="LiveId" clId="{E2C0015B-DB19-4E69-98EF-8810F8F8B916}" dt="2026-10-13T00:40:01.701" v="1206" actId="1076"/>
-          <ac:grpSpMkLst>
-            <pc:docMk/>
-            <pc:sldMk cId="760060564" sldId="265"/>
-            <ac:grpSpMk id="4" creationId="{ABF5922E-D1AF-1DC1-AD25-44351B930879}"/>
-          </ac:grpSpMkLst>
-        </pc:grpChg>
-        <pc:grpChg chg="add mod">
-          <ac:chgData name="Maria Rita" userId="6072d1a607af3438" providerId="LiveId" clId="{E2C0015B-DB19-4E69-98EF-8810F8F8B916}" dt="2026-10-13T00:42:13.044" v="1235" actId="1076"/>
-          <ac:grpSpMkLst>
-            <pc:docMk/>
-            <pc:sldMk cId="760060564" sldId="265"/>
-            <ac:grpSpMk id="5" creationId="{B41AB6EF-BC51-152C-A5B2-2505DC6CAA11}"/>
-          </ac:grpSpMkLst>
-        </pc:grpChg>
-        <pc:grpChg chg="add mod">
-          <ac:chgData name="Maria Rita" userId="6072d1a607af3438" providerId="LiveId" clId="{E2C0015B-DB19-4E69-98EF-8810F8F8B916}" dt="2026-10-13T00:42:20.238" v="1237" actId="1076"/>
-          <ac:grpSpMkLst>
-            <pc:docMk/>
-            <pc:sldMk cId="760060564" sldId="265"/>
-            <ac:grpSpMk id="19" creationId="{FBAC371E-EC1A-46F8-5A20-BE8529371712}"/>
-          </ac:grpSpMkLst>
-        </pc:grpChg>
-        <pc:grpChg chg="add mod ord">
-          <ac:chgData name="Maria Rita" userId="6072d1a607af3438" providerId="LiveId" clId="{E2C0015B-DB19-4E69-98EF-8810F8F8B916}" dt="2026-10-13T00:41:23.850" v="1221" actId="164"/>
-          <ac:grpSpMkLst>
-            <pc:docMk/>
-            <pc:sldMk cId="760060564" sldId="265"/>
-            <ac:grpSpMk id="21" creationId="{C0E987F9-3645-A9F8-2970-CCA7125226C3}"/>
-          </ac:grpSpMkLst>
-        </pc:grpChg>
-        <pc:grpChg chg="add mod">
-          <ac:chgData name="Maria Rita" userId="6072d1a607af3438" providerId="LiveId" clId="{E2C0015B-DB19-4E69-98EF-8810F8F8B916}" dt="2026-10-13T00:31:27.531" v="1067" actId="164"/>
-          <ac:grpSpMkLst>
-            <pc:docMk/>
-            <pc:sldMk cId="760060564" sldId="265"/>
-            <ac:grpSpMk id="24" creationId="{226EE300-ADE2-9D1C-B22F-8B33D82D8CC4}"/>
-          </ac:grpSpMkLst>
-        </pc:grpChg>
-        <pc:grpChg chg="add mod">
-          <ac:chgData name="Maria Rita" userId="6072d1a607af3438" providerId="LiveId" clId="{E2C0015B-DB19-4E69-98EF-8810F8F8B916}" dt="2026-10-13T00:41:42.604" v="1228" actId="1076"/>
-          <ac:grpSpMkLst>
-            <pc:docMk/>
-            <pc:sldMk cId="760060564" sldId="265"/>
-            <ac:grpSpMk id="27" creationId="{07E2DCD2-5192-4AC9-A712-B63E31C08D6A}"/>
-          </ac:grpSpMkLst>
-        </pc:grpChg>
-        <pc:picChg chg="add mod modCrop">
-          <ac:chgData name="Maria Rita" userId="6072d1a607af3438" providerId="LiveId" clId="{E2C0015B-DB19-4E69-98EF-8810F8F8B916}" dt="2026-10-13T00:41:23.850" v="1221" actId="164"/>
-          <ac:picMkLst>
-            <pc:docMk/>
-            <pc:sldMk cId="760060564" sldId="265"/>
-            <ac:picMk id="26" creationId="{C5CA39D5-5415-BD86-98C1-B5D2D5C476E1}"/>
-          </ac:picMkLst>
-        </pc:picChg>
-      </pc:sldChg>
-      <pc:sldChg chg="add del">
-        <pc:chgData name="Maria Rita" userId="6072d1a607af3438" providerId="LiveId" clId="{E2C0015B-DB19-4E69-98EF-8810F8F8B916}" dt="2026-10-13T00:12:19.132" v="579" actId="2890"/>
-        <pc:sldMkLst>
-          <pc:docMk/>
-          <pc:sldMk cId="707577077" sldId="266"/>
-        </pc:sldMkLst>
-      </pc:sldChg>
-      <pc:sldChg chg="add">
-        <pc:chgData name="Maria Rita" userId="6072d1a607af3438" providerId="LiveId" clId="{E2C0015B-DB19-4E69-98EF-8810F8F8B916}" dt="2026-10-13T00:12:40.933" v="587" actId="2890"/>
-        <pc:sldMkLst>
-          <pc:docMk/>
-          <pc:sldMk cId="3969564750" sldId="266"/>
-        </pc:sldMkLst>
-      </pc:sldChg>
-      <pc:sldChg chg="add">
-        <pc:chgData name="Maria Rita" userId="6072d1a607af3438" providerId="LiveId" clId="{E2C0015B-DB19-4E69-98EF-8810F8F8B916}" dt="2026-10-13T00:45:01.438" v="1243" actId="2890"/>
-        <pc:sldMkLst>
-          <pc:docMk/>
-          <pc:sldMk cId="85665319" sldId="267"/>
-        </pc:sldMkLst>
       </pc:sldChg>
     </pc:docChg>
   </pc:docChgLst>
@@ -7187,7 +6784,7 @@
         <p:spPr>
           <a:xfrm>
             <a:off x="8229600" y="3657600"/>
-            <a:ext cx="3108960" cy="1554480"/>
+            <a:ext cx="3108960" cy="1965960"/>
           </a:xfrm>
           <a:prstGeom prst="roundRect">
             <a:avLst/>
@@ -7291,7 +6888,7 @@
               </a:defRPr>
             </a:pPr>
             <a:r>
-              <a:t>K = 22,4987</a:t>
+              <a:t>k = 22,4987</a:t>
             </a:r>
             <a:br/>
             <a:r>
@@ -7300,16 +6897,37 @@
             <a:br/>
             <a:r>
               <a:t>θ = 2,5369 s</a:t>
+            </a:r>
+          </a:p>
+          <a:p>
+            <a:pPr algn="l">
+              <a:spcBef>
+                <a:spcPts val="600"/>
+              </a:spcBef>
+              <a:defRPr sz="1600" b="0">
+                <a:solidFill>
+                  <a:srgbClr val="2B343E"/>
+                </a:solidFill>
+                <a:latin typeface="Aptos"/>
+              </a:defRPr>
+            </a:pPr>
+            <a:r>
+              <a:rPr lang="pt-BR" sz="1200" i="1">
+                <a:solidFill>
+                  <a:srgbClr val="5A6772"/>
+                </a:solidFill>
+              </a:rPr>
+              <a:t>Valores do ensaio: k = 22,5; τ = 20 s; θ = 2,5 s</a:t>
             </a:r>
           </a:p>
         </p:txBody>
       </p:sp>
       <p:pic>
         <p:nvPicPr>
-          <p:cNvPr id="25" name="Imagem 24">
+          <p:cNvPr id="18" name="Imagem 17">
             <a:extLst>
               <a:ext uri="{FF2B5EF4-FFF2-40B4-BE49-F238E27FC236}">
-                <a16:creationId xmlns:a16="http://schemas.microsoft.com/office/drawing/2014/main" id="{8A86A204-936B-4CEA-B2D3-D6EFCE09E405}"/>
+                <a16:creationId xmlns:a16="http://schemas.microsoft.com/office/drawing/2014/main" id="{BC016C3C-5768-3348-99B1-97BCA122B34F}"/>
               </a:ext>
             </a:extLst>
           </p:cNvPr>
@@ -7326,8 +6944,8 @@
         </p:blipFill>
         <p:spPr>
           <a:xfrm>
-            <a:off x="1036320" y="2543898"/>
-            <a:ext cx="6745566" cy="4216799"/>
+            <a:off x="190194" y="2606040"/>
+            <a:ext cx="7856525" cy="3273552"/>
           </a:xfrm>
           <a:prstGeom prst="rect">
             <a:avLst/>
@@ -7376,7 +6994,7 @@
         <p:spPr>
           <a:xfrm>
             <a:off x="594360" y="320040"/>
-            <a:ext cx="10972800" cy="320088"/>
+            <a:ext cx="10972800" cy="475488"/>
           </a:xfrm>
           <a:prstGeom prst="rect">
             <a:avLst/>
@@ -7398,53 +7016,8 @@
               </a:defRPr>
             </a:pPr>
             <a:r>
-              <a:rPr sz="1600" dirty="0">
-                <a:latin typeface="Arial" panose="020B0604020202020204" pitchFamily="34" charset="0"/>
-                <a:cs typeface="Arial" panose="020B0604020202020204" pitchFamily="34" charset="0"/>
-              </a:rPr>
-              <a:t>O que </a:t>
-            </a:r>
-            <a:r>
-              <a:rPr sz="1600" dirty="0" err="1">
-                <a:latin typeface="Arial" panose="020B0604020202020204" pitchFamily="34" charset="0"/>
-                <a:cs typeface="Arial" panose="020B0604020202020204" pitchFamily="34" charset="0"/>
-              </a:rPr>
-              <a:t>mostrou</a:t>
-            </a:r>
-            <a:r>
-              <a:rPr sz="1600" dirty="0">
-                <a:latin typeface="Arial" panose="020B0604020202020204" pitchFamily="34" charset="0"/>
-                <a:cs typeface="Arial" panose="020B0604020202020204" pitchFamily="34" charset="0"/>
-              </a:rPr>
-              <a:t> a </a:t>
-            </a:r>
-            <a:r>
-              <a:rPr sz="1600" dirty="0" err="1">
-                <a:latin typeface="Arial" panose="020B0604020202020204" pitchFamily="34" charset="0"/>
-                <a:cs typeface="Arial" panose="020B0604020202020204" pitchFamily="34" charset="0"/>
-              </a:rPr>
-              <a:t>simulação</a:t>
-            </a:r>
-            <a:r>
-              <a:rPr sz="1600" dirty="0">
-                <a:latin typeface="Arial" panose="020B0604020202020204" pitchFamily="34" charset="0"/>
-                <a:cs typeface="Arial" panose="020B0604020202020204" pitchFamily="34" charset="0"/>
-              </a:rPr>
-              <a:t> da </a:t>
-            </a:r>
-            <a:r>
-              <a:rPr sz="1600" dirty="0" err="1">
-                <a:latin typeface="Arial" panose="020B0604020202020204" pitchFamily="34" charset="0"/>
-                <a:cs typeface="Arial" panose="020B0604020202020204" pitchFamily="34" charset="0"/>
-              </a:rPr>
-              <a:t>sintonia</a:t>
-            </a:r>
-            <a:r>
-              <a:rPr sz="1600" dirty="0">
-                <a:latin typeface="Arial" panose="020B0604020202020204" pitchFamily="34" charset="0"/>
-                <a:cs typeface="Arial" panose="020B0604020202020204" pitchFamily="34" charset="0"/>
-              </a:rPr>
-              <a:t>?</a:t>
+              <a:rPr dirty="0"/>
+              <a:t>Ziegler-Nichols teve a resposta mais rápida</a:t>
             </a:r>
           </a:p>
         </p:txBody>
@@ -7566,30 +7139,6 @@
           </a:p>
         </p:txBody>
       </p:sp>
-      <p:pic>
-        <p:nvPicPr>
-          <p:cNvPr id="6" name="Picture 5" descr="image(20261012-154048).png"/>
-          <p:cNvPicPr>
-            <a:picLocks noChangeAspect="1"/>
-          </p:cNvPicPr>
-          <p:nvPr/>
-        </p:nvPicPr>
-        <p:blipFill>
-          <a:blip r:embed="rId2"/>
-          <a:stretch>
-            <a:fillRect/>
-          </a:stretch>
-        </p:blipFill>
-        <p:spPr>
-          <a:xfrm>
-            <a:off x="594360" y="1583705"/>
-            <a:ext cx="6629400" cy="4193508"/>
-          </a:xfrm>
-          <a:prstGeom prst="rect">
-            <a:avLst/>
-          </a:prstGeom>
-        </p:spPr>
-      </p:pic>
       <p:sp>
         <p:nvSpPr>
           <p:cNvPr id="7" name="Rounded Rectangle 6"/>
@@ -7685,7 +7234,7 @@
         <p:spPr>
           <a:xfrm>
             <a:off x="7635240" y="1946776"/>
-            <a:ext cx="3611879" cy="720197"/>
+            <a:ext cx="3611879" cy="735586"/>
           </a:xfrm>
           <a:prstGeom prst="rect">
             <a:avLst/>
@@ -7698,7 +7247,7 @@
           </a:bodyPr>
           <a:lstStyle/>
           <a:p>
-            <a:pPr algn="l">
+            <a:pPr>
               <a:defRPr sz="1500" b="0">
                 <a:solidFill>
                   <a:srgbClr val="2B343E"/>
@@ -7707,18 +7256,20 @@
               </a:defRPr>
             </a:pPr>
             <a:r>
-              <a:rPr sz="1400" dirty="0" err="1">
-                <a:latin typeface="Arial" panose="020B0604020202020204" pitchFamily="34" charset="0"/>
-                <a:cs typeface="Arial" panose="020B0604020202020204" pitchFamily="34" charset="0"/>
-              </a:rPr>
-              <a:t>Subida</a:t>
-            </a:r>
-            <a:r>
               <a:rPr sz="1400" dirty="0">
                 <a:latin typeface="Arial" panose="020B0604020202020204" pitchFamily="34" charset="0"/>
                 <a:cs typeface="Arial" panose="020B0604020202020204" pitchFamily="34" charset="0"/>
               </a:rPr>
-              <a:t>: 3,184 s</a:t>
+              <a:t>Subida: </a:t>
+            </a:r>
+            <a:r>
+              <a:rPr lang="pt-BR" sz="1500" dirty="0">
+                <a:solidFill>
+                  <a:srgbClr val="2B343E"/>
+                </a:solidFill>
+                <a:latin typeface="Aptos"/>
+              </a:rPr>
+              <a:t>1,198 s</a:t>
             </a:r>
             <a:br>
               <a:rPr sz="1400" dirty="0">
@@ -7873,18 +7424,25 @@
               </a:defRPr>
             </a:pPr>
             <a:r>
-              <a:rPr sz="1400" dirty="0" err="1">
-                <a:latin typeface="Arial" panose="020B0604020202020204" pitchFamily="34" charset="0"/>
-                <a:cs typeface="Arial" panose="020B0604020202020204" pitchFamily="34" charset="0"/>
-              </a:rPr>
-              <a:t>Subida</a:t>
-            </a:r>
-            <a:r>
               <a:rPr sz="1400" dirty="0">
                 <a:latin typeface="Arial" panose="020B0604020202020204" pitchFamily="34" charset="0"/>
                 <a:cs typeface="Arial" panose="020B0604020202020204" pitchFamily="34" charset="0"/>
               </a:rPr>
-              <a:t>: 3,124 s</a:t>
+              <a:t>Subida: </a:t>
+            </a:r>
+            <a:r>
+              <a:rPr lang="pt-BR" sz="1400" dirty="0">
+                <a:latin typeface="Arial" panose="020B0604020202020204" pitchFamily="34" charset="0"/>
+                <a:cs typeface="Arial" panose="020B0604020202020204" pitchFamily="34" charset="0"/>
+              </a:rPr>
+              <a:t>1,147</a:t>
+            </a:r>
+            <a:r>
+              <a:rPr sz="1400" dirty="0">
+                <a:latin typeface="Arial" panose="020B0604020202020204" pitchFamily="34" charset="0"/>
+                <a:cs typeface="Arial" panose="020B0604020202020204" pitchFamily="34" charset="0"/>
+              </a:rPr>
+              <a:t> s</a:t>
             </a:r>
             <a:br>
               <a:rPr sz="1400" dirty="0">
@@ -7931,7 +7489,7 @@
         <p:spPr>
           <a:xfrm>
             <a:off x="7452360" y="4160520"/>
-            <a:ext cx="3977639" cy="1705356"/>
+            <a:ext cx="3977639" cy="2057400"/>
           </a:xfrm>
           <a:prstGeom prst="roundRect">
             <a:avLst/>
@@ -8021,7 +7579,7 @@
         <p:spPr>
           <a:xfrm>
             <a:off x="7635238" y="4446037"/>
-            <a:ext cx="3611879" cy="1366528"/>
+            <a:ext cx="3611879" cy="1797415"/>
           </a:xfrm>
           <a:prstGeom prst="rect">
             <a:avLst/>
@@ -8034,7 +7592,7 @@
           </a:bodyPr>
           <a:lstStyle/>
           <a:p>
-            <a:pPr marL="285750" indent="-285750" algn="l">
+            <a:pPr marL="285750" indent="-285750">
               <a:buFont typeface="Arial" panose="020B0604020202020204" pitchFamily="34" charset="0"/>
               <a:buChar char="•"/>
               <a:defRPr sz="1400" b="0">
@@ -8045,262 +7603,94 @@
               </a:defRPr>
             </a:pPr>
             <a:r>
+              <a:rPr lang="pt-BR" sz="1400" dirty="0">
+                <a:solidFill>
+                  <a:srgbClr val="2B343E"/>
+                </a:solidFill>
+                <a:latin typeface="Arial" panose="020B0604020202020204" pitchFamily="34" charset="0"/>
+                <a:cs typeface="Arial" panose="020B0604020202020204" pitchFamily="34" charset="0"/>
+              </a:rPr>
+              <a:t> ZN acomodou antes (22,74 s contra 23,24 s), subiu um pouco mais rápido (1,15 s contra 1,20 s) e teve menos </a:t>
+            </a:r>
+            <a:r>
+              <a:rPr lang="pt-BR" sz="1400" dirty="0" err="1">
+                <a:solidFill>
+                  <a:srgbClr val="2B343E"/>
+                </a:solidFill>
+                <a:latin typeface="Arial" panose="020B0604020202020204" pitchFamily="34" charset="0"/>
+                <a:cs typeface="Arial" panose="020B0604020202020204" pitchFamily="34" charset="0"/>
+              </a:rPr>
+              <a:t>overshoot</a:t>
+            </a:r>
+            <a:r>
+              <a:rPr lang="pt-BR" sz="1400" dirty="0">
+                <a:solidFill>
+                  <a:srgbClr val="2B343E"/>
+                </a:solidFill>
+                <a:latin typeface="Arial" panose="020B0604020202020204" pitchFamily="34" charset="0"/>
+                <a:cs typeface="Arial" panose="020B0604020202020204" pitchFamily="34" charset="0"/>
+              </a:rPr>
+              <a:t> (69 % contra 84 %).</a:t>
+            </a:r>
+          </a:p>
+          <a:p>
+            <a:pPr marL="285750" indent="-285750">
+              <a:buFont typeface="Arial" panose="020B0604020202020204" pitchFamily="34" charset="0"/>
+              <a:buChar char="•"/>
+              <a:defRPr sz="1400" b="0">
+                <a:solidFill>
+                  <a:srgbClr val="2B343E"/>
+                </a:solidFill>
+                <a:latin typeface="Aptos"/>
+              </a:defRPr>
+            </a:pPr>
+            <a:r>
+              <a:rPr lang="pt-BR" sz="1400" dirty="0">
+                <a:solidFill>
+                  <a:srgbClr val="2B343E"/>
+                </a:solidFill>
+                <a:latin typeface="Aptos"/>
+              </a:rPr>
+              <a:t>"</a:t>
+            </a:r>
+            <a:r>
               <a:rPr dirty="0">
                 <a:latin typeface="Arial" panose="020B0604020202020204" pitchFamily="34" charset="0"/>
                 <a:cs typeface="Arial" panose="020B0604020202020204" pitchFamily="34" charset="0"/>
               </a:rPr>
-              <a:t>Nesta </a:t>
-            </a:r>
-            <a:r>
-              <a:rPr dirty="0" err="1">
-                <a:latin typeface="Arial" panose="020B0604020202020204" pitchFamily="34" charset="0"/>
-                <a:cs typeface="Arial" panose="020B0604020202020204" pitchFamily="34" charset="0"/>
-              </a:rPr>
-              <a:t>simulação</a:t>
-            </a:r>
-            <a:r>
-              <a:rPr dirty="0">
-                <a:latin typeface="Arial" panose="020B0604020202020204" pitchFamily="34" charset="0"/>
-                <a:cs typeface="Arial" panose="020B0604020202020204" pitchFamily="34" charset="0"/>
-              </a:rPr>
-              <a:t>, Ziegler–Nichols </a:t>
-            </a:r>
-            <a:r>
-              <a:rPr dirty="0" err="1">
-                <a:latin typeface="Arial" panose="020B0604020202020204" pitchFamily="34" charset="0"/>
-                <a:cs typeface="Arial" panose="020B0604020202020204" pitchFamily="34" charset="0"/>
-              </a:rPr>
-              <a:t>foi</a:t>
-            </a:r>
-            <a:r>
-              <a:rPr dirty="0">
-                <a:latin typeface="Arial" panose="020B0604020202020204" pitchFamily="34" charset="0"/>
-                <a:cs typeface="Arial" panose="020B0604020202020204" pitchFamily="34" charset="0"/>
-              </a:rPr>
-              <a:t> </a:t>
-            </a:r>
-            <a:r>
-              <a:rPr dirty="0" err="1">
-                <a:latin typeface="Arial" panose="020B0604020202020204" pitchFamily="34" charset="0"/>
-                <a:cs typeface="Arial" panose="020B0604020202020204" pitchFamily="34" charset="0"/>
-              </a:rPr>
-              <a:t>ligeiramente</a:t>
-            </a:r>
-            <a:r>
-              <a:rPr dirty="0">
-                <a:latin typeface="Arial" panose="020B0604020202020204" pitchFamily="34" charset="0"/>
-                <a:cs typeface="Arial" panose="020B0604020202020204" pitchFamily="34" charset="0"/>
-              </a:rPr>
-              <a:t> </a:t>
-            </a:r>
-            <a:r>
-              <a:rPr dirty="0" err="1">
-                <a:latin typeface="Arial" panose="020B0604020202020204" pitchFamily="34" charset="0"/>
-                <a:cs typeface="Arial" panose="020B0604020202020204" pitchFamily="34" charset="0"/>
-              </a:rPr>
-              <a:t>mais</a:t>
-            </a:r>
-            <a:r>
-              <a:rPr dirty="0">
-                <a:latin typeface="Arial" panose="020B0604020202020204" pitchFamily="34" charset="0"/>
-                <a:cs typeface="Arial" panose="020B0604020202020204" pitchFamily="34" charset="0"/>
-              </a:rPr>
-              <a:t> </a:t>
-            </a:r>
-            <a:r>
-              <a:rPr dirty="0" err="1">
-                <a:latin typeface="Arial" panose="020B0604020202020204" pitchFamily="34" charset="0"/>
-                <a:cs typeface="Arial" panose="020B0604020202020204" pitchFamily="34" charset="0"/>
-              </a:rPr>
-              <a:t>rápido</a:t>
-            </a:r>
-            <a:r>
-              <a:rPr dirty="0">
-                <a:latin typeface="Arial" panose="020B0604020202020204" pitchFamily="34" charset="0"/>
-                <a:cs typeface="Arial" panose="020B0604020202020204" pitchFamily="34" charset="0"/>
-              </a:rPr>
-              <a:t> e </a:t>
-            </a:r>
-            <a:r>
-              <a:rPr dirty="0" err="1">
-                <a:latin typeface="Arial" panose="020B0604020202020204" pitchFamily="34" charset="0"/>
-                <a:cs typeface="Arial" panose="020B0604020202020204" pitchFamily="34" charset="0"/>
-              </a:rPr>
-              <a:t>teve</a:t>
-            </a:r>
-            <a:r>
-              <a:rPr dirty="0">
-                <a:latin typeface="Arial" panose="020B0604020202020204" pitchFamily="34" charset="0"/>
-                <a:cs typeface="Arial" panose="020B0604020202020204" pitchFamily="34" charset="0"/>
-              </a:rPr>
-              <a:t> </a:t>
-            </a:r>
-            <a:r>
-              <a:rPr dirty="0" err="1">
-                <a:latin typeface="Arial" panose="020B0604020202020204" pitchFamily="34" charset="0"/>
-                <a:cs typeface="Arial" panose="020B0604020202020204" pitchFamily="34" charset="0"/>
-              </a:rPr>
-              <a:t>menor</a:t>
-            </a:r>
-            <a:r>
-              <a:rPr dirty="0">
-                <a:latin typeface="Arial" panose="020B0604020202020204" pitchFamily="34" charset="0"/>
-                <a:cs typeface="Arial" panose="020B0604020202020204" pitchFamily="34" charset="0"/>
-              </a:rPr>
-              <a:t> overshoot.</a:t>
+              <a:t>O Cohen-Coon foi proposto para θ/τ &gt; 0,3. Com θ/τ = 0,127, ele fica mais agressivo (Kp maior) sem ganhar velocidade.</a:t>
             </a:r>
             <a:endParaRPr lang="pt-BR" dirty="0">
               <a:latin typeface="Arial" panose="020B0604020202020204" pitchFamily="34" charset="0"/>
               <a:cs typeface="Arial" panose="020B0604020202020204" pitchFamily="34" charset="0"/>
             </a:endParaRPr>
           </a:p>
-          <a:p>
-            <a:pPr marL="285750" indent="-285750" algn="l">
-              <a:buFont typeface="Arial" panose="020B0604020202020204" pitchFamily="34" charset="0"/>
-              <a:buChar char="•"/>
-              <a:defRPr sz="1400" b="0">
-                <a:solidFill>
-                  <a:srgbClr val="2B343E"/>
-                </a:solidFill>
-                <a:latin typeface="Aptos"/>
-              </a:defRPr>
-            </a:pPr>
-            <a:r>
-              <a:rPr dirty="0">
-                <a:latin typeface="Arial" panose="020B0604020202020204" pitchFamily="34" charset="0"/>
-                <a:cs typeface="Arial" panose="020B0604020202020204" pitchFamily="34" charset="0"/>
-              </a:rPr>
-              <a:t> Ambos </a:t>
-            </a:r>
-            <a:r>
-              <a:rPr dirty="0" err="1">
-                <a:latin typeface="Arial" panose="020B0604020202020204" pitchFamily="34" charset="0"/>
-                <a:cs typeface="Arial" panose="020B0604020202020204" pitchFamily="34" charset="0"/>
-              </a:rPr>
-              <a:t>chegaram</a:t>
-            </a:r>
-            <a:r>
-              <a:rPr dirty="0">
-                <a:latin typeface="Arial" panose="020B0604020202020204" pitchFamily="34" charset="0"/>
-                <a:cs typeface="Arial" panose="020B0604020202020204" pitchFamily="34" charset="0"/>
-              </a:rPr>
-              <a:t> </a:t>
-            </a:r>
-            <a:r>
-              <a:rPr dirty="0" err="1">
-                <a:latin typeface="Arial" panose="020B0604020202020204" pitchFamily="34" charset="0"/>
-                <a:cs typeface="Arial" panose="020B0604020202020204" pitchFamily="34" charset="0"/>
-              </a:rPr>
-              <a:t>ao</a:t>
-            </a:r>
-            <a:r>
-              <a:rPr dirty="0">
-                <a:latin typeface="Arial" panose="020B0604020202020204" pitchFamily="34" charset="0"/>
-                <a:cs typeface="Arial" panose="020B0604020202020204" pitchFamily="34" charset="0"/>
-              </a:rPr>
-              <a:t> </a:t>
-            </a:r>
-            <a:r>
-              <a:rPr dirty="0" err="1">
-                <a:latin typeface="Arial" panose="020B0604020202020204" pitchFamily="34" charset="0"/>
-                <a:cs typeface="Arial" panose="020B0604020202020204" pitchFamily="34" charset="0"/>
-              </a:rPr>
-              <a:t>SetPoint</a:t>
-            </a:r>
-            <a:r>
-              <a:rPr dirty="0">
-                <a:latin typeface="Arial" panose="020B0604020202020204" pitchFamily="34" charset="0"/>
-                <a:cs typeface="Arial" panose="020B0604020202020204" pitchFamily="34" charset="0"/>
-              </a:rPr>
-              <a:t> </a:t>
-            </a:r>
-            <a:r>
-              <a:rPr dirty="0" err="1">
-                <a:latin typeface="Arial" panose="020B0604020202020204" pitchFamily="34" charset="0"/>
-                <a:cs typeface="Arial" panose="020B0604020202020204" pitchFamily="34" charset="0"/>
-              </a:rPr>
-              <a:t>em</a:t>
-            </a:r>
-            <a:r>
-              <a:rPr dirty="0">
-                <a:latin typeface="Arial" panose="020B0604020202020204" pitchFamily="34" charset="0"/>
-                <a:cs typeface="Arial" panose="020B0604020202020204" pitchFamily="34" charset="0"/>
-              </a:rPr>
-              <a:t> regime </a:t>
-            </a:r>
-            <a:r>
-              <a:rPr dirty="0" err="1">
-                <a:latin typeface="Arial" panose="020B0604020202020204" pitchFamily="34" charset="0"/>
-                <a:cs typeface="Arial" panose="020B0604020202020204" pitchFamily="34" charset="0"/>
-              </a:rPr>
-              <a:t>permanente</a:t>
-            </a:r>
-            <a:r>
-              <a:rPr dirty="0">
-                <a:latin typeface="Arial" panose="020B0604020202020204" pitchFamily="34" charset="0"/>
-                <a:cs typeface="Arial" panose="020B0604020202020204" pitchFamily="34" charset="0"/>
-              </a:rPr>
-              <a:t>, mas as </a:t>
-            </a:r>
-            <a:r>
-              <a:rPr dirty="0" err="1">
-                <a:latin typeface="Arial" panose="020B0604020202020204" pitchFamily="34" charset="0"/>
-                <a:cs typeface="Arial" panose="020B0604020202020204" pitchFamily="34" charset="0"/>
-              </a:rPr>
-              <a:t>oscilações</a:t>
-            </a:r>
-            <a:r>
-              <a:rPr dirty="0">
-                <a:latin typeface="Arial" panose="020B0604020202020204" pitchFamily="34" charset="0"/>
-                <a:cs typeface="Arial" panose="020B0604020202020204" pitchFamily="34" charset="0"/>
-              </a:rPr>
-              <a:t> </a:t>
-            </a:r>
-            <a:r>
-              <a:rPr dirty="0" err="1">
-                <a:latin typeface="Arial" panose="020B0604020202020204" pitchFamily="34" charset="0"/>
-                <a:cs typeface="Arial" panose="020B0604020202020204" pitchFamily="34" charset="0"/>
-              </a:rPr>
-              <a:t>iniciais</a:t>
-            </a:r>
-            <a:r>
-              <a:rPr dirty="0">
-                <a:latin typeface="Arial" panose="020B0604020202020204" pitchFamily="34" charset="0"/>
-                <a:cs typeface="Arial" panose="020B0604020202020204" pitchFamily="34" charset="0"/>
-              </a:rPr>
-              <a:t> </a:t>
-            </a:r>
-            <a:r>
-              <a:rPr dirty="0" err="1">
-                <a:latin typeface="Arial" panose="020B0604020202020204" pitchFamily="34" charset="0"/>
-                <a:cs typeface="Arial" panose="020B0604020202020204" pitchFamily="34" charset="0"/>
-              </a:rPr>
-              <a:t>foram</a:t>
-            </a:r>
-            <a:r>
-              <a:rPr dirty="0">
-                <a:latin typeface="Arial" panose="020B0604020202020204" pitchFamily="34" charset="0"/>
-                <a:cs typeface="Arial" panose="020B0604020202020204" pitchFamily="34" charset="0"/>
-              </a:rPr>
-              <a:t> </a:t>
-            </a:r>
-            <a:r>
-              <a:rPr dirty="0" err="1">
-                <a:latin typeface="Arial" panose="020B0604020202020204" pitchFamily="34" charset="0"/>
-                <a:cs typeface="Arial" panose="020B0604020202020204" pitchFamily="34" charset="0"/>
-              </a:rPr>
-              <a:t>elevadas</a:t>
-            </a:r>
-            <a:r>
-              <a:rPr dirty="0">
-                <a:latin typeface="Arial" panose="020B0604020202020204" pitchFamily="34" charset="0"/>
-                <a:cs typeface="Arial" panose="020B0604020202020204" pitchFamily="34" charset="0"/>
-              </a:rPr>
-              <a:t>.</a:t>
-            </a:r>
-          </a:p>
-        </p:txBody>
-      </p:sp>
+        </p:txBody>
+      </p:sp>
+      <p:pic>
+        <p:nvPicPr>
+          <p:cNvPr id="16" name="Picture 15" descr="comparacao_pid.png"/>
+          <p:cNvPicPr>
+            <a:picLocks noChangeAspect="1"/>
+          </p:cNvPicPr>
+          <p:nvPr/>
+        </p:nvPicPr>
+        <p:blipFill>
+          <a:blip r:embed="rId2"/>
+          <a:stretch>
+            <a:fillRect/>
+          </a:stretch>
+        </p:blipFill>
+        <p:spPr>
+          <a:xfrm>
+            <a:off x="594360" y="1583705"/>
+            <a:ext cx="6629400" cy="4143375"/>
+          </a:xfrm>
+          <a:prstGeom prst="rect">
+            <a:avLst/>
+          </a:prstGeom>
+        </p:spPr>
+      </p:pic>
     </p:spTree>
   </p:cSld>
   <p:clrMapOvr>
@@ -8589,8 +7979,8 @@
             </a:p>
           </p:txBody>
         </p:sp>
-        <mc:AlternateContent xmlns:mc="http://schemas.openxmlformats.org/markup-compatibility/2006">
-          <mc:Choice xmlns:a14="http://schemas.microsoft.com/office/drawing/2010/main" Requires="a14">
+        <mc:AlternateContent xmlns:mc="http://schemas.openxmlformats.org/markup-compatibility/2006" xmlns:a14="http://schemas.microsoft.com/office/drawing/2010/main">
+          <mc:Choice Requires="a14">
             <p:sp>
               <p:nvSpPr>
                 <p:cNvPr id="8" name="TextBox 7"/>
@@ -8644,29 +8034,75 @@
                     <m:oMathPara xmlns:m="http://schemas.openxmlformats.org/officeDocument/2006/math">
                       <m:oMath>
                         <m:r>
-                          <m:rPr>
-                            <m:nor/>
-                          </m:rPr>
-                          <a:rPr lang="pt-BR" sz="1700">
-                            <a:solidFill>
-                              <a:srgbClr val="2B343E"/>
-                            </a:solidFill>
-                            <a:latin typeface="Aptos"/>
+                          <a:rPr lang="pt-BR" sz="1400" b="0" i="1" smtClean="0">
+                            <a:latin typeface="Cambria Math" panose="02040503050406030204" pitchFamily="18" charset="0"/>
+                            <a:cs typeface="Arial" panose="020B0604020202020204" pitchFamily="34" charset="0"/>
                           </a:rPr>
-                          <m:t> </m:t>
+                          <m:t>𝑇</m:t>
                         </m:r>
                         <m:r>
-                          <m:rPr>
-                            <m:nor/>
-                          </m:rPr>
-                          <a:rPr lang="pt-BR" sz="1700" b="0" i="0" smtClean="0">
-                            <a:solidFill>
-                              <a:srgbClr val="2B343E"/>
-                            </a:solidFill>
-                            <a:latin typeface="Aptos"/>
+                          <a:rPr lang="pt-BR" sz="1400" b="0" i="1" smtClean="0">
+                            <a:latin typeface="Cambria Math" panose="02040503050406030204" pitchFamily="18" charset="0"/>
+                            <a:cs typeface="Arial" panose="020B0604020202020204" pitchFamily="34" charset="0"/>
                           </a:rPr>
-                          <m:t>T=K_t I_a</m:t>
+                          <m:t>=</m:t>
                         </m:r>
+                        <m:sSub>
+                          <m:sSubPr>
+                            <m:ctrlPr>
+                              <a:rPr lang="pt-BR" sz="1400" b="0" i="1" smtClean="0">
+                                <a:latin typeface="Cambria Math" panose="02040503050406030204" pitchFamily="18" charset="0"/>
+                                <a:cs typeface="Arial" panose="020B0604020202020204" pitchFamily="34" charset="0"/>
+                              </a:rPr>
+                            </m:ctrlPr>
+                          </m:sSubPr>
+                          <m:e>
+                            <m:r>
+                              <a:rPr lang="pt-BR" sz="1400" b="0" i="1" smtClean="0">
+                                <a:latin typeface="Cambria Math" panose="02040503050406030204" pitchFamily="18" charset="0"/>
+                                <a:cs typeface="Arial" panose="020B0604020202020204" pitchFamily="34" charset="0"/>
+                              </a:rPr>
+                              <m:t>𝐾</m:t>
+                            </m:r>
+                          </m:e>
+                          <m:sub>
+                            <m:r>
+                              <a:rPr lang="pt-BR" sz="1400" b="0" i="1" smtClean="0">
+                                <a:latin typeface="Cambria Math" panose="02040503050406030204" pitchFamily="18" charset="0"/>
+                                <a:cs typeface="Arial" panose="020B0604020202020204" pitchFamily="34" charset="0"/>
+                              </a:rPr>
+                              <m:t>𝑡</m:t>
+                            </m:r>
+                          </m:sub>
+                        </m:sSub>
+                        <m:sSub>
+                          <m:sSubPr>
+                            <m:ctrlPr>
+                              <a:rPr lang="pt-BR" sz="1400" b="0" i="1" smtClean="0">
+                                <a:latin typeface="Cambria Math" panose="02040503050406030204" pitchFamily="18" charset="0"/>
+                                <a:cs typeface="Arial" panose="020B0604020202020204" pitchFamily="34" charset="0"/>
+                              </a:rPr>
+                            </m:ctrlPr>
+                          </m:sSubPr>
+                          <m:e>
+                            <m:r>
+                              <a:rPr lang="pt-BR" sz="1400" b="0" i="1" smtClean="0">
+                                <a:latin typeface="Cambria Math" panose="02040503050406030204" pitchFamily="18" charset="0"/>
+                                <a:cs typeface="Arial" panose="020B0604020202020204" pitchFamily="34" charset="0"/>
+                              </a:rPr>
+                              <m:t>𝐼</m:t>
+                            </m:r>
+                          </m:e>
+                          <m:sub>
+                            <m:r>
+                              <a:rPr lang="pt-BR" sz="1400" b="0" i="1" smtClean="0">
+                                <a:latin typeface="Cambria Math" panose="02040503050406030204" pitchFamily="18" charset="0"/>
+                                <a:cs typeface="Arial" panose="020B0604020202020204" pitchFamily="34" charset="0"/>
+                              </a:rPr>
+                              <m:t>𝑎</m:t>
+                            </m:r>
+                          </m:sub>
+                        </m:sSub>
                       </m:oMath>
                     </m:oMathPara>
                   </a14:m>
@@ -8781,13 +8217,13 @@
                       <a:latin typeface="Arial" panose="020B0604020202020204" pitchFamily="34" charset="0"/>
                       <a:cs typeface="Arial" panose="020B0604020202020204" pitchFamily="34" charset="0"/>
                     </a:rPr>
-                    <a:t>A força contra eletromotriz é o que estabiliza a velocidade, sendo assim, quanto mais rápido, menor a corrente e o torque.</a:t>
+                    <a:t>A força contraeletromotriz é o que estabiliza a velocidade, sendo assim, quanto mais rápido, menor a corrente e o torque.</a:t>
                   </a:r>
                 </a:p>
               </p:txBody>
             </p:sp>
           </mc:Choice>
-          <mc:Fallback>
+          <mc:Fallback xmlns="">
             <p:sp>
               <p:nvSpPr>
                 <p:cNvPr id="8" name="TextBox 7"/>
@@ -9717,10 +9153,10 @@
       </p:sp>
       <p:grpSp>
         <p:nvGrpSpPr>
-          <p:cNvPr id="4" name="Agrupar 3">
+          <p:cNvPr id="10" name="Agrupar 9">
             <a:extLst>
               <a:ext uri="{FF2B5EF4-FFF2-40B4-BE49-F238E27FC236}">
-                <a16:creationId xmlns:a16="http://schemas.microsoft.com/office/drawing/2014/main" id="{1D913A5F-FDEC-8607-ADE8-A9127271F4D0}"/>
+                <a16:creationId xmlns:a16="http://schemas.microsoft.com/office/drawing/2014/main" id="{ED4E764B-E095-69E8-0D5A-507CD0553EBB}"/>
               </a:ext>
             </a:extLst>
           </p:cNvPr>
@@ -9729,10 +9165,10 @@
         </p:nvGrpSpPr>
         <p:grpSpPr>
           <a:xfrm>
-            <a:off x="644436" y="1624010"/>
-            <a:ext cx="3484154" cy="3254822"/>
+            <a:off x="6891049" y="1694760"/>
+            <a:ext cx="3148099" cy="2820366"/>
             <a:chOff x="621792" y="1653628"/>
-            <a:chExt cx="5254750" cy="2611522"/>
+            <a:chExt cx="4636008" cy="3383280"/>
           </a:xfrm>
         </p:grpSpPr>
         <p:sp>
@@ -9744,7 +9180,7 @@
           <p:spPr>
             <a:xfrm>
               <a:off x="621792" y="1653628"/>
-              <a:ext cx="5254750" cy="2441772"/>
+              <a:ext cx="4526280" cy="3383280"/>
             </a:xfrm>
             <a:prstGeom prst="roundRect">
               <a:avLst/>
@@ -9789,8 +9225,8 @@
           </p:nvSpPr>
           <p:spPr>
             <a:xfrm>
-              <a:off x="987553" y="1750532"/>
-              <a:ext cx="4800601" cy="304547"/>
+              <a:off x="941833" y="1763356"/>
+              <a:ext cx="4206239" cy="379566"/>
             </a:xfrm>
             <a:prstGeom prst="rect">
               <a:avLst/>
@@ -9833,8 +9269,8 @@
           </p:nvSpPr>
           <p:spPr>
             <a:xfrm>
-              <a:off x="848866" y="2342125"/>
-              <a:ext cx="4800601" cy="1923025"/>
+              <a:off x="822960" y="2220556"/>
+              <a:ext cx="4434840" cy="1955581"/>
             </a:xfrm>
             <a:prstGeom prst="rect">
               <a:avLst/>
@@ -9858,11 +9294,11 @@
                 </a:defRPr>
               </a:pPr>
               <a:r>
-                <a:rPr lang="pt-BR" b="1" dirty="0">
+                <a:rPr lang="pt-BR" sz="1200" b="1" dirty="0">
                   <a:latin typeface="Arial" panose="020B0604020202020204" pitchFamily="34" charset="0"/>
                   <a:cs typeface="Arial" panose="020B0604020202020204" pitchFamily="34" charset="0"/>
                 </a:rPr>
-                <a:t>1501 amostras.</a:t>
+                <a:t>1501 amostras, de 0 a 150 s</a:t>
               </a:r>
             </a:p>
             <a:p>
@@ -9874,7 +9310,7 @@
                   <a:latin typeface="Aptos"/>
                 </a:defRPr>
               </a:pPr>
-              <a:endParaRPr lang="pt-BR" b="1" dirty="0">
+              <a:endParaRPr lang="pt-BR" sz="1200" b="1" dirty="0">
                 <a:latin typeface="Arial" panose="020B0604020202020204" pitchFamily="34" charset="0"/>
                 <a:cs typeface="Arial" panose="020B0604020202020204" pitchFamily="34" charset="0"/>
               </a:endParaRPr>
@@ -9891,17 +9327,15 @@
                 </a:defRPr>
               </a:pPr>
               <a:r>
-                <a:rPr lang="pt-BR" b="1" dirty="0">
+                <a:rPr lang="pt-BR" sz="1200" b="1" dirty="0">
                   <a:latin typeface="Arial" panose="020B0604020202020204" pitchFamily="34" charset="0"/>
                   <a:cs typeface="Arial" panose="020B0604020202020204" pitchFamily="34" charset="0"/>
                 </a:rPr>
-                <a:t>150 s</a:t>
+                <a:t>Uma amostra a cada 0,1 s</a:t>
               </a:r>
             </a:p>
             <a:p>
-              <a:pPr marL="285750" indent="-285750" algn="l">
-                <a:buFont typeface="Arial" panose="020B0604020202020204" pitchFamily="34" charset="0"/>
-                <a:buChar char="•"/>
+              <a:pPr algn="l">
                 <a:defRPr sz="1700" b="0">
                   <a:solidFill>
                     <a:srgbClr val="2B343E"/>
@@ -9909,7 +9343,7 @@
                   <a:latin typeface="Aptos"/>
                 </a:defRPr>
               </a:pPr>
-              <a:endParaRPr lang="pt-BR" b="1" dirty="0">
+              <a:endParaRPr lang="pt-BR" sz="1200" b="1" dirty="0">
                 <a:latin typeface="Arial" panose="020B0604020202020204" pitchFamily="34" charset="0"/>
                 <a:cs typeface="Arial" panose="020B0604020202020204" pitchFamily="34" charset="0"/>
               </a:endParaRPr>
@@ -9926,112 +9360,32 @@
                 </a:defRPr>
               </a:pPr>
               <a:r>
-                <a:rPr lang="pt-BR" b="1" dirty="0">
+                <a:rPr lang="pt-BR" sz="1200" b="1" dirty="0">
                   <a:latin typeface="Arial" panose="020B0604020202020204" pitchFamily="34" charset="0"/>
                   <a:cs typeface="Arial" panose="020B0604020202020204" pitchFamily="34" charset="0"/>
                 </a:rPr>
-                <a:t>Uma amostra a cada 0,1 s.</a:t>
+                <a:t>Degrau de 0 a 80% em t = 10 s</a:t>
               </a:r>
-              <a:endParaRPr b="1" dirty="0">
+            </a:p>
+            <a:p>
+              <a:pPr algn="l">
+                <a:defRPr sz="1700" b="0">
+                  <a:solidFill>
+                    <a:srgbClr val="2B343E"/>
+                  </a:solidFill>
+                  <a:latin typeface="Aptos"/>
+                </a:defRPr>
+              </a:pPr>
+              <a:endParaRPr lang="pt-BR" sz="1200" b="1" dirty="0">
                 <a:latin typeface="Arial" panose="020B0604020202020204" pitchFamily="34" charset="0"/>
                 <a:cs typeface="Arial" panose="020B0604020202020204" pitchFamily="34" charset="0"/>
               </a:endParaRPr>
             </a:p>
-          </p:txBody>
-        </p:sp>
-      </p:grpSp>
-      <p:grpSp>
-        <p:nvGrpSpPr>
-          <p:cNvPr id="18" name="Agrupar 17">
-            <a:extLst>
-              <a:ext uri="{FF2B5EF4-FFF2-40B4-BE49-F238E27FC236}">
-                <a16:creationId xmlns:a16="http://schemas.microsoft.com/office/drawing/2014/main" id="{2FF8D55D-2B89-0BDC-B855-E461198775C1}"/>
-              </a:ext>
-            </a:extLst>
-          </p:cNvPr>
-          <p:cNvGrpSpPr/>
-          <p:nvPr/>
-        </p:nvGrpSpPr>
-        <p:grpSpPr>
-          <a:xfrm>
-            <a:off x="4552479" y="1624010"/>
-            <a:ext cx="5119115" cy="1268581"/>
-            <a:chOff x="5960364" y="1901551"/>
-            <a:chExt cx="5119115" cy="1268581"/>
-          </a:xfrm>
-        </p:grpSpPr>
-        <p:sp>
-          <p:nvSpPr>
-            <p:cNvPr id="9" name="Rounded Rectangle 8"/>
-            <p:cNvSpPr/>
-            <p:nvPr/>
-          </p:nvSpPr>
-          <p:spPr>
-            <a:xfrm>
-              <a:off x="5960364" y="1901551"/>
-              <a:ext cx="4606036" cy="1268581"/>
-            </a:xfrm>
-            <a:prstGeom prst="roundRect">
-              <a:avLst/>
-            </a:prstGeom>
-            <a:solidFill>
-              <a:srgbClr val="F0F5F8"/>
-            </a:solidFill>
-            <a:ln>
-              <a:solidFill>
-                <a:srgbClr val="DCE5EB"/>
-              </a:solidFill>
-            </a:ln>
-          </p:spPr>
-          <p:style>
-            <a:lnRef idx="1">
-              <a:schemeClr val="accent1"/>
-            </a:lnRef>
-            <a:fillRef idx="3">
-              <a:schemeClr val="accent1"/>
-            </a:fillRef>
-            <a:effectRef idx="2">
-              <a:schemeClr val="accent1"/>
-            </a:effectRef>
-            <a:fontRef idx="minor">
-              <a:schemeClr val="lt1"/>
-            </a:fontRef>
-          </p:style>
-          <p:txBody>
-            <a:bodyPr rtlCol="0" anchor="ctr"/>
-            <a:lstStyle/>
             <a:p>
-              <a:pPr algn="ctr"/>
-              <a:endParaRPr/>
-            </a:p>
-          </p:txBody>
-        </p:sp>
-        <p:sp>
-          <p:nvSpPr>
-            <p:cNvPr id="11" name="TextBox 10"/>
-            <p:cNvSpPr txBox="1"/>
-            <p:nvPr/>
-          </p:nvSpPr>
-          <p:spPr>
-            <a:xfrm>
-              <a:off x="6096000" y="2161633"/>
-              <a:ext cx="4983479" cy="720197"/>
-            </a:xfrm>
-            <a:prstGeom prst="rect">
-              <a:avLst/>
-            </a:prstGeom>
-            <a:noFill/>
-          </p:spPr>
-          <p:txBody>
-            <a:bodyPr wrap="square" lIns="45720" tIns="36576" rIns="45720" bIns="36576" anchor="t">
-              <a:spAutoFit/>
-            </a:bodyPr>
-            <a:lstStyle/>
-            <a:p>
-              <a:pPr marL="285750" indent="-285750" algn="l">
+              <a:pPr marL="285750" indent="-285750">
                 <a:buFont typeface="Arial" panose="020B0604020202020204" pitchFamily="34" charset="0"/>
                 <a:buChar char="•"/>
-                <a:defRPr sz="1600" b="0">
+                <a:defRPr sz="1700" b="0">
                   <a:solidFill>
                     <a:srgbClr val="2B343E"/>
                   </a:solidFill>
@@ -10039,34 +9393,16 @@
                 </a:defRPr>
               </a:pPr>
               <a:r>
-                <a:rPr lang="pt-BR" sz="1400" dirty="0">
+                <a:rPr lang="pt-BR" sz="1200" b="1" dirty="0">
                   <a:latin typeface="Arial" panose="020B0604020202020204" pitchFamily="34" charset="0"/>
                   <a:cs typeface="Arial" panose="020B0604020202020204" pitchFamily="34" charset="0"/>
                 </a:rPr>
-                <a:t>O degrau de 0 à 80% em t = 10s.</a:t>
+                <a:t>Saída de ≈ 0 a 1797 RPM</a:t>
               </a:r>
             </a:p>
             <a:p>
-              <a:pPr marL="285750" indent="-285750" algn="l">
-                <a:buFont typeface="Arial" panose="020B0604020202020204" pitchFamily="34" charset="0"/>
-                <a:buChar char="•"/>
-                <a:defRPr sz="1600" b="0">
-                  <a:solidFill>
-                    <a:srgbClr val="2B343E"/>
-                  </a:solidFill>
-                  <a:latin typeface="Aptos"/>
-                </a:defRPr>
-              </a:pPr>
-              <a:endParaRPr lang="pt-BR" sz="1400" dirty="0">
-                <a:latin typeface="Arial" panose="020B0604020202020204" pitchFamily="34" charset="0"/>
-                <a:cs typeface="Arial" panose="020B0604020202020204" pitchFamily="34" charset="0"/>
-              </a:endParaRPr>
-            </a:p>
-            <a:p>
-              <a:pPr marL="285750" indent="-285750" algn="l">
-                <a:buFont typeface="Arial" panose="020B0604020202020204" pitchFamily="34" charset="0"/>
-                <a:buChar char="•"/>
-                <a:defRPr sz="1600" b="0">
+              <a:pPr lvl="1">
+                <a:defRPr sz="1700" b="0">
                   <a:solidFill>
                     <a:srgbClr val="2B343E"/>
                   </a:solidFill>
@@ -10074,124 +9410,57 @@
                 </a:defRPr>
               </a:pPr>
               <a:r>
-                <a:rPr lang="pt-BR" sz="1400" dirty="0">
+                <a:rPr lang="pt-BR" sz="1200" b="1" dirty="0">
+                  <a:solidFill>
+                    <a:srgbClr val="2B343E"/>
+                  </a:solidFill>
                   <a:latin typeface="Arial" panose="020B0604020202020204" pitchFamily="34" charset="0"/>
                   <a:cs typeface="Arial" panose="020B0604020202020204" pitchFamily="34" charset="0"/>
                 </a:rPr>
-                <a:t>A saída vai de a aproximadamente 1800 RPM.</a:t>
+                <a:t>	</a:t>
               </a:r>
-              <a:endParaRPr sz="1400" dirty="0">
+              <a:r>
+                <a:rPr lang="pt-BR" sz="1200" b="1" dirty="0" err="1">
+                  <a:solidFill>
+                    <a:srgbClr val="2B343E"/>
+                  </a:solidFill>
+                  <a:latin typeface="Arial" panose="020B0604020202020204" pitchFamily="34" charset="0"/>
+                  <a:cs typeface="Arial" panose="020B0604020202020204" pitchFamily="34" charset="0"/>
+                </a:rPr>
+                <a:t>Δy</a:t>
+              </a:r>
+              <a:r>
+                <a:rPr lang="pt-BR" sz="1200" b="1" dirty="0">
+                  <a:solidFill>
+                    <a:srgbClr val="2B343E"/>
+                  </a:solidFill>
+                  <a:latin typeface="Arial" panose="020B0604020202020204" pitchFamily="34" charset="0"/>
+                  <a:cs typeface="Arial" panose="020B0604020202020204" pitchFamily="34" charset="0"/>
+                </a:rPr>
+                <a:t> ≈ 1798 RPM </a:t>
+              </a:r>
+            </a:p>
+            <a:p>
+              <a:pPr marL="742950" lvl="1" indent="-285750">
+                <a:buFont typeface="Arial" panose="020B0604020202020204" pitchFamily="34" charset="0"/>
+                <a:buChar char="•"/>
+                <a:defRPr sz="1700" b="0">
+                  <a:solidFill>
+                    <a:srgbClr val="2B343E"/>
+                  </a:solidFill>
+                  <a:latin typeface="Aptos"/>
+                </a:defRPr>
+              </a:pPr>
+              <a:endParaRPr lang="pt-BR" sz="1200" b="1" dirty="0">
                 <a:latin typeface="Arial" panose="020B0604020202020204" pitchFamily="34" charset="0"/>
                 <a:cs typeface="Arial" panose="020B0604020202020204" pitchFamily="34" charset="0"/>
               </a:endParaRPr>
             </a:p>
-          </p:txBody>
-        </p:sp>
-      </p:grpSp>
-      <p:grpSp>
-        <p:nvGrpSpPr>
-          <p:cNvPr id="17" name="Agrupar 16">
-            <a:extLst>
-              <a:ext uri="{FF2B5EF4-FFF2-40B4-BE49-F238E27FC236}">
-                <a16:creationId xmlns:a16="http://schemas.microsoft.com/office/drawing/2014/main" id="{D00D8935-475A-EDD4-8E76-A5AF334EDE12}"/>
-              </a:ext>
-            </a:extLst>
-          </p:cNvPr>
-          <p:cNvGrpSpPr/>
-          <p:nvPr/>
-        </p:nvGrpSpPr>
-        <p:grpSpPr>
-          <a:xfrm>
-            <a:off x="4552479" y="3429000"/>
-            <a:ext cx="4606036" cy="1268581"/>
-            <a:chOff x="2034249" y="4262278"/>
-            <a:chExt cx="4606036" cy="1268581"/>
-          </a:xfrm>
-        </p:grpSpPr>
-        <p:sp>
-          <p:nvSpPr>
-            <p:cNvPr id="12" name="Rounded Rectangle 8">
-              <a:extLst>
-                <a:ext uri="{FF2B5EF4-FFF2-40B4-BE49-F238E27FC236}">
-                  <a16:creationId xmlns:a16="http://schemas.microsoft.com/office/drawing/2014/main" id="{260A5732-61CA-E2D1-CCB0-A380A53FD303}"/>
-                </a:ext>
-              </a:extLst>
-            </p:cNvPr>
-            <p:cNvSpPr/>
-            <p:nvPr/>
-          </p:nvSpPr>
-          <p:spPr>
-            <a:xfrm>
-              <a:off x="2034249" y="4262278"/>
-              <a:ext cx="4606036" cy="1268581"/>
-            </a:xfrm>
-            <a:prstGeom prst="roundRect">
-              <a:avLst/>
-            </a:prstGeom>
-            <a:solidFill>
-              <a:srgbClr val="F0F5F8"/>
-            </a:solidFill>
-            <a:ln>
-              <a:solidFill>
-                <a:srgbClr val="DCE5EB"/>
-              </a:solidFill>
-            </a:ln>
-          </p:spPr>
-          <p:style>
-            <a:lnRef idx="1">
-              <a:schemeClr val="accent1"/>
-            </a:lnRef>
-            <a:fillRef idx="3">
-              <a:schemeClr val="accent1"/>
-            </a:fillRef>
-            <a:effectRef idx="2">
-              <a:schemeClr val="accent1"/>
-            </a:effectRef>
-            <a:fontRef idx="minor">
-              <a:schemeClr val="lt1"/>
-            </a:fontRef>
-          </p:style>
-          <p:txBody>
-            <a:bodyPr rtlCol="0" anchor="ctr"/>
-            <a:lstStyle/>
-            <a:p>
-              <a:pPr algn="ctr"/>
-              <a:endParaRPr dirty="0"/>
-            </a:p>
-          </p:txBody>
-        </p:sp>
-        <p:sp>
-          <p:nvSpPr>
-            <p:cNvPr id="16" name="TextBox 10">
-              <a:extLst>
-                <a:ext uri="{FF2B5EF4-FFF2-40B4-BE49-F238E27FC236}">
-                  <a16:creationId xmlns:a16="http://schemas.microsoft.com/office/drawing/2014/main" id="{021F7662-C79F-175F-064C-1B5CE20D93BF}"/>
-                </a:ext>
-              </a:extLst>
-            </p:cNvPr>
-            <p:cNvSpPr txBox="1"/>
-            <p:nvPr/>
-          </p:nvSpPr>
-          <p:spPr>
-            <a:xfrm>
-              <a:off x="2334334" y="4634227"/>
-              <a:ext cx="3746426" cy="720197"/>
-            </a:xfrm>
-            <a:prstGeom prst="rect">
-              <a:avLst/>
-            </a:prstGeom>
-            <a:noFill/>
-          </p:spPr>
-          <p:txBody>
-            <a:bodyPr wrap="square" lIns="45720" tIns="36576" rIns="45720" bIns="36576" anchor="t">
-              <a:spAutoFit/>
-            </a:bodyPr>
-            <a:lstStyle/>
             <a:p>
               <a:pPr marL="285750" indent="-285750" algn="l">
                 <a:buFont typeface="Arial" panose="020B0604020202020204" pitchFamily="34" charset="0"/>
                 <a:buChar char="•"/>
-                <a:defRPr sz="1600" b="0">
+                <a:defRPr sz="1700" b="0">
                   <a:solidFill>
                     <a:srgbClr val="2B343E"/>
                   </a:solidFill>
@@ -10199,32 +9468,132 @@
                 </a:defRPr>
               </a:pPr>
               <a:r>
-                <a:rPr lang="pt-BR" sz="1400" dirty="0">
+                <a:rPr lang="pt-BR" sz="1200" b="1" dirty="0">
                   <a:latin typeface="Arial" panose="020B0604020202020204" pitchFamily="34" charset="0"/>
                   <a:cs typeface="Arial" panose="020B0604020202020204" pitchFamily="34" charset="0"/>
                 </a:rPr>
-                <a:t>Ruído de mediação de aproximadamente 10 RPM</a:t>
+                <a:t>Ruído de medição de ≈ 10 RPM</a:t>
               </a:r>
-            </a:p>
-            <a:p>
-              <a:pPr marL="285750" indent="-285750" algn="l">
-                <a:buFont typeface="Arial" panose="020B0604020202020204" pitchFamily="34" charset="0"/>
-                <a:buChar char="•"/>
-                <a:defRPr sz="1600" b="0">
-                  <a:solidFill>
-                    <a:srgbClr val="2B343E"/>
-                  </a:solidFill>
-                  <a:latin typeface="Aptos"/>
-                </a:defRPr>
-              </a:pPr>
-              <a:endParaRPr lang="pt-BR" sz="1400" dirty="0">
-                <a:latin typeface="Arial" panose="020B0604020202020204" pitchFamily="34" charset="0"/>
-                <a:cs typeface="Arial" panose="020B0604020202020204" pitchFamily="34" charset="0"/>
-              </a:endParaRPr>
             </a:p>
           </p:txBody>
         </p:sp>
       </p:grpSp>
+      <p:pic>
+        <p:nvPicPr>
+          <p:cNvPr id="5" name="Imagem 4">
+            <a:extLst>
+              <a:ext uri="{FF2B5EF4-FFF2-40B4-BE49-F238E27FC236}">
+                <a16:creationId xmlns:a16="http://schemas.microsoft.com/office/drawing/2014/main" id="{952443D1-4CE6-42B1-F3FF-BFA2A9A94372}"/>
+              </a:ext>
+            </a:extLst>
+          </p:cNvPr>
+          <p:cNvPicPr>
+            <a:picLocks noChangeAspect="1"/>
+          </p:cNvPicPr>
+          <p:nvPr/>
+        </p:nvPicPr>
+        <p:blipFill>
+          <a:blip r:embed="rId2"/>
+          <a:stretch>
+            <a:fillRect/>
+          </a:stretch>
+        </p:blipFill>
+        <p:spPr>
+          <a:xfrm>
+            <a:off x="282505" y="1114613"/>
+            <a:ext cx="6369059" cy="3980661"/>
+          </a:xfrm>
+          <a:prstGeom prst="rect">
+            <a:avLst/>
+          </a:prstGeom>
+        </p:spPr>
+      </p:pic>
+      <p:sp>
+        <p:nvSpPr>
+          <p:cNvPr id="14" name="TextBox 17">
+            <a:extLst>
+              <a:ext uri="{FF2B5EF4-FFF2-40B4-BE49-F238E27FC236}">
+                <a16:creationId xmlns:a16="http://schemas.microsoft.com/office/drawing/2014/main" id="{DBE1854F-0A3B-EEAB-173F-A48B80902037}"/>
+              </a:ext>
+            </a:extLst>
+          </p:cNvPr>
+          <p:cNvSpPr txBox="1"/>
+          <p:nvPr/>
+        </p:nvSpPr>
+        <p:spPr>
+          <a:xfrm>
+            <a:off x="822960" y="6312408"/>
+            <a:ext cx="10515600" cy="320088"/>
+          </a:xfrm>
+          <a:prstGeom prst="rect">
+            <a:avLst/>
+          </a:prstGeom>
+          <a:noFill/>
+        </p:spPr>
+        <p:txBody>
+          <a:bodyPr wrap="square" lIns="45720" tIns="36576" rIns="45720" bIns="36576" anchor="t">
+            <a:spAutoFit/>
+          </a:bodyPr>
+          <a:lstStyle/>
+          <a:p>
+            <a:pPr>
+              <a:defRPr sz="1600" b="1">
+                <a:solidFill>
+                  <a:srgbClr val="182B45"/>
+                </a:solidFill>
+                <a:latin typeface="Aptos"/>
+              </a:defRPr>
+            </a:pPr>
+            <a:r>
+              <a:rPr lang="pt-BR" sz="1400" dirty="0">
+                <a:latin typeface="Arial" panose="020B0604020202020204" pitchFamily="34" charset="0"/>
+                <a:cs typeface="Arial" panose="020B0604020202020204" pitchFamily="34" charset="0"/>
+              </a:rPr>
+              <a:t>Ganho estático: k = </a:t>
+            </a:r>
+            <a:r>
+              <a:rPr lang="pt-BR" sz="1600" dirty="0" err="1">
+                <a:solidFill>
+                  <a:srgbClr val="182B45"/>
+                </a:solidFill>
+                <a:latin typeface="Aptos"/>
+              </a:rPr>
+              <a:t>Δy</a:t>
+            </a:r>
+            <a:r>
+              <a:rPr lang="pt-BR" sz="1600" dirty="0">
+                <a:solidFill>
+                  <a:srgbClr val="182B45"/>
+                </a:solidFill>
+                <a:latin typeface="Aptos"/>
+              </a:rPr>
+              <a:t>/</a:t>
+            </a:r>
+            <a:r>
+              <a:rPr lang="pt-BR" sz="1600" dirty="0" err="1">
+                <a:solidFill>
+                  <a:srgbClr val="182B45"/>
+                </a:solidFill>
+                <a:latin typeface="Aptos"/>
+              </a:rPr>
+              <a:t>Δu</a:t>
+            </a:r>
+            <a:r>
+              <a:rPr lang="pt-BR" sz="1600" dirty="0">
+                <a:solidFill>
+                  <a:srgbClr val="182B45"/>
+                </a:solidFill>
+                <a:latin typeface="Aptos"/>
+              </a:rPr>
+              <a:t> ≈ 1798/80 ≈ 22,5 RPM/% .</a:t>
+            </a:r>
+            <a:endParaRPr sz="1400" dirty="0">
+              <a:latin typeface="Arial" panose="020B0604020202020204" pitchFamily="34" charset="0"/>
+              <a:cs typeface="Arial" panose="020B0604020202020204" pitchFamily="34" charset="0"/>
+            </a:endParaRPr>
+          </a:p>
+        </p:txBody>
+      </p:sp>
     </p:spTree>
   </p:cSld>
   <p:clrMapOvr>
@@ -13268,7 +12637,7 @@
         </p:nvSpPr>
         <p:spPr>
           <a:xfrm>
-            <a:off x="6038088" y="1624011"/>
+            <a:off x="6038088" y="1653628"/>
             <a:ext cx="5254750" cy="2441772"/>
           </a:xfrm>
           <a:prstGeom prst="roundRect">
@@ -13320,7 +12689,7 @@
         </p:nvSpPr>
         <p:spPr>
           <a:xfrm>
-            <a:off x="6309359" y="1733734"/>
+            <a:off x="6309359" y="1763351"/>
             <a:ext cx="4983479" cy="289310"/>
           </a:xfrm>
           <a:prstGeom prst="rect">
@@ -13380,7 +12749,7 @@
         </p:nvSpPr>
         <p:spPr>
           <a:xfrm>
-            <a:off x="6103618" y="2292282"/>
+            <a:off x="6103618" y="2321899"/>
             <a:ext cx="4983479" cy="1366528"/>
           </a:xfrm>
           <a:prstGeom prst="rect">
@@ -13796,6 +13165,250 @@
           </a:p>
         </p:txBody>
       </p:sp>
+      <p:sp>
+        <p:nvSpPr>
+          <p:cNvPr id="5001" name="Rounded Rectangle 5">
+            <a:extLst>
+              <a:ext uri="{FF2B5EF4-FFF2-40B4-BE49-F238E27FC236}">
+                <a16:creationId xmlns:a16="http://schemas.microsoft.com/office/drawing/2014/main" id="{2C59A055-DC60-0F53-4602-ED44AEC8BF99}"/>
+              </a:ext>
+            </a:extLst>
+          </p:cNvPr>
+          <p:cNvSpPr/>
+          <p:nvPr/>
+        </p:nvSpPr>
+        <p:spPr>
+          <a:xfrm>
+            <a:off x="566930" y="4297680"/>
+            <a:ext cx="5254750" cy="1828800"/>
+          </a:xfrm>
+          <a:prstGeom prst="roundRect">
+            <a:avLst/>
+          </a:prstGeom>
+          <a:solidFill>
+            <a:srgbClr val="F0F5F8"/>
+          </a:solidFill>
+          <a:ln>
+            <a:solidFill>
+              <a:srgbClr val="DCE5EB"/>
+            </a:solidFill>
+          </a:ln>
+        </p:spPr>
+        <p:style>
+          <a:lnRef idx="1">
+            <a:schemeClr val="accent1"/>
+          </a:lnRef>
+          <a:fillRef idx="3">
+            <a:schemeClr val="accent1"/>
+          </a:fillRef>
+          <a:effectRef idx="2">
+            <a:schemeClr val="accent1"/>
+          </a:effectRef>
+          <a:fontRef idx="minor">
+            <a:schemeClr val="lt1"/>
+          </a:fontRef>
+        </p:style>
+        <p:txBody>
+          <a:bodyPr rtlCol="0" anchor="ctr"/>
+          <a:lstStyle/>
+          <a:p>
+            <a:pPr algn="ctr"/>
+            <a:endParaRPr/>
+          </a:p>
+        </p:txBody>
+      </p:sp>
+      <p:sp>
+        <p:nvSpPr>
+          <p:cNvPr id="5002" name="TextBox 6">
+            <a:extLst>
+              <a:ext uri="{FF2B5EF4-FFF2-40B4-BE49-F238E27FC236}">
+                <a16:creationId xmlns:a16="http://schemas.microsoft.com/office/drawing/2014/main" id="{262C5124-C0B3-39B9-09BB-2463CDA4E52C}"/>
+              </a:ext>
+            </a:extLst>
+          </p:cNvPr>
+          <p:cNvSpPr txBox="1"/>
+          <p:nvPr/>
+        </p:nvSpPr>
+        <p:spPr>
+          <a:xfrm>
+            <a:off x="987552" y="4407408"/>
+            <a:ext cx="4800600" cy="289310"/>
+          </a:xfrm>
+          <a:prstGeom prst="rect">
+            <a:avLst/>
+          </a:prstGeom>
+          <a:noFill/>
+        </p:spPr>
+        <p:txBody>
+          <a:bodyPr wrap="square" lIns="45720" tIns="36576" rIns="45720" bIns="36576" anchor="t">
+            <a:spAutoFit/>
+          </a:bodyPr>
+          <a:lstStyle/>
+          <a:p>
+            <a:pPr algn="l">
+              <a:defRPr sz="1500" b="1">
+                <a:solidFill>
+                  <a:srgbClr val="16847E"/>
+                </a:solidFill>
+                <a:latin typeface="Aptos"/>
+              </a:defRPr>
+            </a:pPr>
+            <a:r>
+              <a:rPr sz="1400" dirty="0">
+                <a:latin typeface="Arial" panose="020B0604020202020204" pitchFamily="34" charset="0"/>
+                <a:cs typeface="Arial" panose="020B0604020202020204" pitchFamily="34" charset="0"/>
+              </a:rPr>
+              <a:t>Smith: pontos de 28,3% e 63,2%</a:t>
+            </a:r>
+          </a:p>
+        </p:txBody>
+      </p:sp>
+      <p:pic>
+        <p:nvPicPr>
+          <p:cNvPr id="5003" name="Picture 5002" descr="formula_smith.png"/>
+          <p:cNvPicPr>
+            <a:picLocks noChangeAspect="1"/>
+          </p:cNvPicPr>
+          <p:nvPr/>
+        </p:nvPicPr>
+        <p:blipFill>
+          <a:blip r:embed="rId2"/>
+          <a:stretch>
+            <a:fillRect/>
+          </a:stretch>
+        </p:blipFill>
+        <p:spPr>
+          <a:xfrm>
+            <a:off x="1091185" y="5261485"/>
+            <a:ext cx="4206240" cy="449829"/>
+          </a:xfrm>
+          <a:prstGeom prst="rect">
+            <a:avLst/>
+          </a:prstGeom>
+        </p:spPr>
+      </p:pic>
+      <p:sp>
+        <p:nvSpPr>
+          <p:cNvPr id="4" name="Rounded Rectangle 5">
+            <a:extLst>
+              <a:ext uri="{FF2B5EF4-FFF2-40B4-BE49-F238E27FC236}">
+                <a16:creationId xmlns:a16="http://schemas.microsoft.com/office/drawing/2014/main" id="{2C59A055-DC60-0F53-4602-ED44AEC8BF99}"/>
+              </a:ext>
+            </a:extLst>
+          </p:cNvPr>
+          <p:cNvSpPr/>
+          <p:nvPr/>
+        </p:nvSpPr>
+        <p:spPr>
+          <a:xfrm>
+            <a:off x="6038088" y="4297680"/>
+            <a:ext cx="5254750" cy="1828800"/>
+          </a:xfrm>
+          <a:prstGeom prst="roundRect">
+            <a:avLst/>
+          </a:prstGeom>
+          <a:solidFill>
+            <a:srgbClr val="F0F5F8"/>
+          </a:solidFill>
+          <a:ln>
+            <a:solidFill>
+              <a:srgbClr val="DCE5EB"/>
+            </a:solidFill>
+          </a:ln>
+        </p:spPr>
+        <p:style>
+          <a:lnRef idx="1">
+            <a:schemeClr val="accent1"/>
+          </a:lnRef>
+          <a:fillRef idx="3">
+            <a:schemeClr val="accent1"/>
+          </a:fillRef>
+          <a:effectRef idx="2">
+            <a:schemeClr val="accent1"/>
+          </a:effectRef>
+          <a:fontRef idx="minor">
+            <a:schemeClr val="lt1"/>
+          </a:fontRef>
+        </p:style>
+        <p:txBody>
+          <a:bodyPr rtlCol="0" anchor="ctr"/>
+          <a:lstStyle/>
+          <a:p>
+            <a:pPr algn="ctr"/>
+            <a:endParaRPr/>
+          </a:p>
+        </p:txBody>
+      </p:sp>
+      <p:sp>
+        <p:nvSpPr>
+          <p:cNvPr id="5004" name="TextBox 6">
+            <a:extLst>
+              <a:ext uri="{FF2B5EF4-FFF2-40B4-BE49-F238E27FC236}">
+                <a16:creationId xmlns:a16="http://schemas.microsoft.com/office/drawing/2014/main" id="{262C5124-C0B3-39B9-09BB-2463CDA4E52C}"/>
+              </a:ext>
+            </a:extLst>
+          </p:cNvPr>
+          <p:cNvSpPr txBox="1"/>
+          <p:nvPr/>
+        </p:nvSpPr>
+        <p:spPr>
+          <a:xfrm>
+            <a:off x="6458710" y="4407408"/>
+            <a:ext cx="4800600" cy="289310"/>
+          </a:xfrm>
+          <a:prstGeom prst="rect">
+            <a:avLst/>
+          </a:prstGeom>
+          <a:noFill/>
+        </p:spPr>
+        <p:txBody>
+          <a:bodyPr wrap="square" lIns="45720" tIns="36576" rIns="45720" bIns="36576" anchor="t">
+            <a:spAutoFit/>
+          </a:bodyPr>
+          <a:lstStyle/>
+          <a:p>
+            <a:pPr algn="l">
+              <a:defRPr sz="1500" b="1">
+                <a:solidFill>
+                  <a:srgbClr val="16847E"/>
+                </a:solidFill>
+                <a:latin typeface="Aptos"/>
+              </a:defRPr>
+            </a:pPr>
+            <a:r>
+              <a:rPr sz="1400" dirty="0">
+                <a:latin typeface="Arial" panose="020B0604020202020204" pitchFamily="34" charset="0"/>
+                <a:cs typeface="Arial" panose="020B0604020202020204" pitchFamily="34" charset="0"/>
+              </a:rPr>
+              <a:t>Sundaresan: pontos de 35,3% e 85,3%</a:t>
+            </a:r>
+          </a:p>
+        </p:txBody>
+      </p:sp>
+      <p:pic>
+        <p:nvPicPr>
+          <p:cNvPr id="5005" name="Picture 5004" descr="formula_sundaresan.png"/>
+          <p:cNvPicPr>
+            <a:picLocks noChangeAspect="1"/>
+          </p:cNvPicPr>
+          <p:nvPr/>
+        </p:nvPicPr>
+        <p:blipFill>
+          <a:blip r:embed="rId3"/>
+          <a:stretch>
+            <a:fillRect/>
+          </a:stretch>
+        </p:blipFill>
+        <p:spPr>
+          <a:xfrm>
+            <a:off x="6425183" y="5193619"/>
+            <a:ext cx="4480560" cy="585561"/>
+          </a:xfrm>
+          <a:prstGeom prst="rect">
+            <a:avLst/>
+          </a:prstGeom>
+        </p:spPr>
+      </p:pic>
     </p:spTree>
     <p:extLst>
       <p:ext uri="{BB962C8B-B14F-4D97-AF65-F5344CB8AC3E}">
@@ -13842,20 +13455,257 @@
         </p:nvPicPr>
         <p:blipFill>
           <a:blip r:embed="rId2"/>
+          <a:srcRect t="600"/>
           <a:stretch>
             <a:fillRect/>
           </a:stretch>
         </p:blipFill>
         <p:spPr>
           <a:xfrm>
-            <a:off x="711167" y="143166"/>
-            <a:ext cx="9705975" cy="6086475"/>
+            <a:off x="594360" y="1188720"/>
+            <a:ext cx="7874143" cy="4937760"/>
           </a:xfrm>
           <a:prstGeom prst="rect">
             <a:avLst/>
           </a:prstGeom>
         </p:spPr>
       </p:pic>
+      <p:sp>
+        <p:nvSpPr>
+          <p:cNvPr id="5005" name="TextBox 1">
+            <a:extLst>
+              <a:ext uri="{FF2B5EF4-FFF2-40B4-BE49-F238E27FC236}">
+                <a16:creationId xmlns:a16="http://schemas.microsoft.com/office/drawing/2014/main" id="{47C04E18-E261-BE10-B838-2AF46A02074B}"/>
+              </a:ext>
+            </a:extLst>
+          </p:cNvPr>
+          <p:cNvSpPr txBox="1"/>
+          <p:nvPr/>
+        </p:nvSpPr>
+        <p:spPr>
+          <a:xfrm>
+            <a:off x="594360" y="320040"/>
+            <a:ext cx="10972800" cy="475488"/>
+          </a:xfrm>
+          <a:prstGeom prst="rect">
+            <a:avLst/>
+          </a:prstGeom>
+          <a:noFill/>
+        </p:spPr>
+        <p:txBody>
+          <a:bodyPr wrap="square" lIns="45720" tIns="36576" rIns="45720" bIns="36576" anchor="t">
+            <a:spAutoFit/>
+          </a:bodyPr>
+          <a:lstStyle/>
+          <a:p>
+            <a:pPr algn="l">
+              <a:defRPr sz="2700" b="1">
+                <a:solidFill>
+                  <a:srgbClr val="182B45"/>
+                </a:solidFill>
+                <a:latin typeface="Aptos"/>
+              </a:defRPr>
+            </a:pPr>
+            <a:r>
+              <a:rPr dirty="0" err="1"/>
+              <a:t>Smith acompanha melhor a curva real</a:t>
+            </a:r>
+            <a:endParaRPr dirty="0"/>
+          </a:p>
+        </p:txBody>
+      </p:sp>
+      <p:sp>
+        <p:nvSpPr>
+          <p:cNvPr id="5006" name="Rectangle 2">
+            <a:extLst>
+              <a:ext uri="{FF2B5EF4-FFF2-40B4-BE49-F238E27FC236}">
+                <a16:creationId xmlns:a16="http://schemas.microsoft.com/office/drawing/2014/main" id="{4715ECD5-9010-6CB9-0E07-A7ACC3966873}"/>
+              </a:ext>
+            </a:extLst>
+          </p:cNvPr>
+          <p:cNvSpPr/>
+          <p:nvPr/>
+        </p:nvSpPr>
+        <p:spPr>
+          <a:xfrm>
+            <a:off x="621792" y="896112"/>
+            <a:ext cx="731520" cy="50292"/>
+          </a:xfrm>
+          <a:prstGeom prst="rect">
+            <a:avLst/>
+          </a:prstGeom>
+          <a:solidFill>
+            <a:srgbClr val="16847E"/>
+          </a:solidFill>
+          <a:ln>
+            <a:noFill/>
+          </a:ln>
+        </p:spPr>
+        <p:style>
+          <a:lnRef idx="1">
+            <a:schemeClr val="accent1"/>
+          </a:lnRef>
+          <a:fillRef idx="3">
+            <a:schemeClr val="accent1"/>
+          </a:fillRef>
+          <a:effectRef idx="2">
+            <a:schemeClr val="accent1"/>
+          </a:effectRef>
+          <a:fontRef idx="minor">
+            <a:schemeClr val="lt1"/>
+          </a:fontRef>
+        </p:style>
+        <p:txBody>
+          <a:bodyPr rtlCol="0" anchor="ctr"/>
+          <a:lstStyle/>
+          <a:p>
+            <a:pPr algn="ctr"/>
+            <a:endParaRPr/>
+          </a:p>
+        </p:txBody>
+      </p:sp>
+      <p:sp>
+        <p:nvSpPr>
+          <p:cNvPr id="5007" name="Rounded Rectangle 14"/>
+          <p:cNvSpPr/>
+          <p:nvPr/>
+        </p:nvSpPr>
+        <p:spPr>
+          <a:xfrm>
+            <a:off x="8686800" y="1554480"/>
+            <a:ext cx="2743200" cy="2834640"/>
+          </a:xfrm>
+          <a:prstGeom prst="roundRect">
+            <a:avLst/>
+          </a:prstGeom>
+          <a:solidFill>
+            <a:srgbClr val="F0F5F8"/>
+          </a:solidFill>
+          <a:ln>
+            <a:solidFill>
+              <a:srgbClr val="DCE5EB"/>
+            </a:solidFill>
+          </a:ln>
+        </p:spPr>
+        <p:style>
+          <a:lnRef idx="1">
+            <a:schemeClr val="accent1"/>
+          </a:lnRef>
+          <a:fillRef idx="3">
+            <a:schemeClr val="accent1"/>
+          </a:fillRef>
+          <a:effectRef idx="2">
+            <a:schemeClr val="accent1"/>
+          </a:effectRef>
+          <a:fontRef idx="minor">
+            <a:schemeClr val="lt1"/>
+          </a:fontRef>
+        </p:style>
+        <p:txBody>
+          <a:bodyPr rtlCol="0" anchor="ctr"/>
+          <a:lstStyle/>
+          <a:p>
+            <a:pPr algn="ctr"/>
+            <a:endParaRPr/>
+          </a:p>
+        </p:txBody>
+      </p:sp>
+      <p:sp>
+        <p:nvSpPr>
+          <p:cNvPr id="5008" name="TextBox 15"/>
+          <p:cNvSpPr txBox="1"/>
+          <p:nvPr/>
+        </p:nvSpPr>
+        <p:spPr>
+          <a:xfrm>
+            <a:off x="8869680" y="1682496"/>
+            <a:ext cx="2377440" cy="274320"/>
+          </a:xfrm>
+          <a:prstGeom prst="rect">
+            <a:avLst/>
+          </a:prstGeom>
+          <a:noFill/>
+        </p:spPr>
+        <p:txBody>
+          <a:bodyPr wrap="square" lIns="45720" tIns="36576" rIns="45720" bIns="36576" anchor="t">
+            <a:spAutoFit/>
+          </a:bodyPr>
+          <a:lstStyle/>
+          <a:p>
+            <a:pPr algn="l">
+              <a:defRPr sz="1500" b="1">
+                <a:solidFill>
+                  <a:srgbClr val="CD7731"/>
+                </a:solidFill>
+                <a:latin typeface="Aptos"/>
+              </a:defRPr>
+            </a:pPr>
+            <a:r>
+              <a:t>Por que Smith?</a:t>
+            </a:r>
+          </a:p>
+        </p:txBody>
+      </p:sp>
+      <p:sp>
+        <p:nvSpPr>
+          <p:cNvPr id="5009" name="TextBox 16"/>
+          <p:cNvSpPr txBox="1"/>
+          <p:nvPr/>
+        </p:nvSpPr>
+        <p:spPr>
+          <a:xfrm>
+            <a:off x="8869680" y="2057400"/>
+            <a:ext cx="2377440" cy="2286000"/>
+          </a:xfrm>
+          <a:prstGeom prst="rect">
+            <a:avLst/>
+          </a:prstGeom>
+          <a:noFill/>
+        </p:spPr>
+        <p:txBody>
+          <a:bodyPr wrap="square" lIns="45720" tIns="36576" rIns="45720" bIns="36576" anchor="t">
+            <a:spAutoFit/>
+          </a:bodyPr>
+          <a:lstStyle/>
+          <a:p>
+            <a:pPr algn="l">
+              <a:defRPr sz="1400" b="0">
+                <a:solidFill>
+                  <a:srgbClr val="2B343E"/>
+                </a:solidFill>
+                <a:latin typeface="Aptos"/>
+              </a:defRPr>
+            </a:pPr>
+            <a:r>
+              <a:t>Menor EQM: 10,46 contra 16,37 RPM.</a:t>
+            </a:r>
+          </a:p>
+          <a:p>
+            <a:pPr algn="l">
+              <a:defRPr sz="1400" b="0">
+                <a:solidFill>
+                  <a:srgbClr val="2B343E"/>
+                </a:solidFill>
+                <a:latin typeface="Aptos"/>
+              </a:defRPr>
+            </a:pPr>
+            <a:endParaRPr/>
+          </a:p>
+          <a:p>
+            <a:pPr algn="l">
+              <a:defRPr sz="1400" b="0">
+                <a:solidFill>
+                  <a:srgbClr val="2B343E"/>
+                </a:solidFill>
+                <a:latin typeface="Aptos"/>
+              </a:defRPr>
+            </a:pPr>
+            <a:r>
+              <a:t>O ponto de 85,3% do Sundaresan fica na parte achatada da curva, onde o ruído desloca o cruzamento. Por isso o θ saiu maior: 3,21 s contra 2,47 s.</a:t>
+            </a:r>
+          </a:p>
+        </p:txBody>
+      </p:sp>
     </p:spTree>
     <p:extLst>
       <p:ext uri="{BB962C8B-B14F-4D97-AF65-F5344CB8AC3E}">
@@ -14124,4 +13974,285 @@
     </a:ext>
   </a:extLst>
 </a:theme>
+</file>
+
+<file path=customXml/item1.xml><?xml version="1.0" encoding="utf-8"?>
+<?mso-contentType ?>
+<FormTemplates xmlns="http://schemas.microsoft.com/sharepoint/v3/contenttype/forms">
+  <Display>DocumentLibraryForm</Display>
+  <Edit>DocumentLibraryForm</Edit>
+  <New>DocumentLibraryForm</New>
+</FormTemplates>
+</file>
+
+<file path=customXml/item2.xml><?xml version="1.0" encoding="utf-8"?>
+<ct:contentTypeSchema xmlns:ct="http://schemas.microsoft.com/office/2006/metadata/contentType" xmlns:ma="http://schemas.microsoft.com/office/2006/metadata/properties/metaAttributes" ct:_="" ma:_="" ma:contentTypeName="Document" ma:contentTypeID="0x010100410913E91E3223419314E4EEAF55D6B7" ma:contentTypeVersion="14" ma:contentTypeDescription="Create a new document." ma:contentTypeScope="" ma:versionID="f5daf4d97800b124ae3bcd4663ff1978">
+  <xsd:schema xmlns:xsd="http://www.w3.org/2001/XMLSchema" xmlns:xs="http://www.w3.org/2001/XMLSchema" xmlns:p="http://schemas.microsoft.com/office/2006/metadata/properties" xmlns:ns3="39687eec-9f0c-43bc-aa81-f41a7d22872d" xmlns:ns4="e9ac9483-9538-4d01-9b68-bc5731453717" targetNamespace="http://schemas.microsoft.com/office/2006/metadata/properties" ma:root="true" ma:fieldsID="24b8c66475976e2de1d2b339beb70633" ns3:_="" ns4:_="">
+    <xsd:import namespace="39687eec-9f0c-43bc-aa81-f41a7d22872d"/>
+    <xsd:import namespace="e9ac9483-9538-4d01-9b68-bc5731453717"/>
+    <xsd:element name="properties">
+      <xsd:complexType>
+        <xsd:sequence>
+          <xsd:element name="documentManagement">
+            <xsd:complexType>
+              <xsd:all>
+                <xsd:element ref="ns3:MediaServiceMetadata" minOccurs="0"/>
+                <xsd:element ref="ns3:MediaServiceFastMetadata" minOccurs="0"/>
+                <xsd:element ref="ns3:MediaServiceSearchProperties" minOccurs="0"/>
+                <xsd:element ref="ns4:SharedWithUsers" minOccurs="0"/>
+                <xsd:element ref="ns4:SharedWithDetails" minOccurs="0"/>
+                <xsd:element ref="ns4:SharingHintHash" minOccurs="0"/>
+                <xsd:element ref="ns3:_activity" minOccurs="0"/>
+                <xsd:element ref="ns3:MediaServiceObjectDetectorVersions" minOccurs="0"/>
+                <xsd:element ref="ns3:MediaServiceSystemTags" minOccurs="0"/>
+                <xsd:element ref="ns3:MediaServiceOCR" minOccurs="0"/>
+                <xsd:element ref="ns3:MediaServiceGenerationTime" minOccurs="0"/>
+                <xsd:element ref="ns3:MediaServiceEventHashCode" minOccurs="0"/>
+                <xsd:element ref="ns3:MediaServiceDateTaken" minOccurs="0"/>
+                <xsd:element ref="ns3:MediaLengthInSeconds" minOccurs="0"/>
+              </xsd:all>
+            </xsd:complexType>
+          </xsd:element>
+        </xsd:sequence>
+      </xsd:complexType>
+    </xsd:element>
+  </xsd:schema>
+  <xsd:schema xmlns:xsd="http://www.w3.org/2001/XMLSchema" xmlns:xs="http://www.w3.org/2001/XMLSchema" xmlns:dms="http://schemas.microsoft.com/office/2006/documentManagement/types" xmlns:pc="http://schemas.microsoft.com/office/infopath/2007/PartnerControls" targetNamespace="39687eec-9f0c-43bc-aa81-f41a7d22872d" elementFormDefault="qualified">
+    <xsd:import namespace="http://schemas.microsoft.com/office/2006/documentManagement/types"/>
+    <xsd:import namespace="http://schemas.microsoft.com/office/infopath/2007/PartnerControls"/>
+    <xsd:element name="MediaServiceMetadata" ma:index="8" nillable="true" ma:displayName="MediaServiceMetadata" ma:hidden="true" ma:internalName="MediaServiceMetadata" ma:readOnly="true">
+      <xsd:simpleType>
+        <xsd:restriction base="dms:Note"/>
+      </xsd:simpleType>
+    </xsd:element>
+    <xsd:element name="MediaServiceFastMetadata" ma:index="9" nillable="true" ma:displayName="MediaServiceFastMetadata" ma:hidden="true" ma:internalName="MediaServiceFastMetadata" ma:readOnly="true">
+      <xsd:simpleType>
+        <xsd:restriction base="dms:Note"/>
+      </xsd:simpleType>
+    </xsd:element>
+    <xsd:element name="MediaServiceSearchProperties" ma:index="10" nillable="true" ma:displayName="MediaServiceSearchProperties" ma:hidden="true" ma:internalName="MediaServiceSearchProperties" ma:readOnly="true">
+      <xsd:simpleType>
+        <xsd:restriction base="dms:Note"/>
+      </xsd:simpleType>
+    </xsd:element>
+    <xsd:element name="_activity" ma:index="14" nillable="true" ma:displayName="_activity" ma:hidden="true" ma:internalName="_activity">
+      <xsd:simpleType>
+        <xsd:restriction base="dms:Note"/>
+      </xsd:simpleType>
+    </xsd:element>
+    <xsd:element name="MediaServiceObjectDetectorVersions" ma:index="15" nillable="true" ma:displayName="MediaServiceObjectDetectorVersions" ma:hidden="true" ma:indexed="true" ma:internalName="MediaServiceObjectDetectorVersions" ma:readOnly="true">
+      <xsd:simpleType>
+        <xsd:restriction base="dms:Text"/>
+      </xsd:simpleType>
+    </xsd:element>
+    <xsd:element name="MediaServiceSystemTags" ma:index="16" nillable="true" ma:displayName="MediaServiceSystemTags" ma:hidden="true" ma:internalName="MediaServiceSystemTags" ma:readOnly="true">
+      <xsd:simpleType>
+        <xsd:restriction base="dms:Note"/>
+      </xsd:simpleType>
+    </xsd:element>
+    <xsd:element name="MediaServiceOCR" ma:index="17" nillable="true" ma:displayName="Extracted Text" ma:internalName="MediaServiceOCR" ma:readOnly="true">
+      <xsd:simpleType>
+        <xsd:restriction base="dms:Note">
+          <xsd:maxLength value="255"/>
+        </xsd:restriction>
+      </xsd:simpleType>
+    </xsd:element>
+    <xsd:element name="MediaServiceGenerationTime" ma:index="18" nillable="true" ma:displayName="MediaServiceGenerationTime" ma:hidden="true" ma:internalName="MediaServiceGenerationTime" ma:readOnly="true">
+      <xsd:simpleType>
+        <xsd:restriction base="dms:Text"/>
+      </xsd:simpleType>
+    </xsd:element>
+    <xsd:element name="MediaServiceEventHashCode" ma:index="19" nillable="true" ma:displayName="MediaServiceEventHashCode" ma:hidden="true" ma:internalName="MediaServiceEventHashCode" ma:readOnly="true">
+      <xsd:simpleType>
+        <xsd:restriction base="dms:Text"/>
+      </xsd:simpleType>
+    </xsd:element>
+    <xsd:element name="MediaServiceDateTaken" ma:index="20" nillable="true" ma:displayName="MediaServiceDateTaken" ma:hidden="true" ma:indexed="true" ma:internalName="MediaServiceDateTaken" ma:readOnly="true">
+      <xsd:simpleType>
+        <xsd:restriction base="dms:Text"/>
+      </xsd:simpleType>
+    </xsd:element>
+    <xsd:element name="MediaLengthInSeconds" ma:index="21" nillable="true" ma:displayName="MediaLengthInSeconds" ma:hidden="true" ma:internalName="MediaLengthInSeconds" ma:readOnly="true">
+      <xsd:simpleType>
+        <xsd:restriction base="dms:Unknown"/>
+      </xsd:simpleType>
+    </xsd:element>
+  </xsd:schema>
+  <xsd:schema xmlns:xsd="http://www.w3.org/2001/XMLSchema" xmlns:xs="http://www.w3.org/2001/XMLSchema" xmlns:dms="http://schemas.microsoft.com/office/2006/documentManagement/types" xmlns:pc="http://schemas.microsoft.com/office/infopath/2007/PartnerControls" targetNamespace="e9ac9483-9538-4d01-9b68-bc5731453717" elementFormDefault="qualified">
+    <xsd:import namespace="http://schemas.microsoft.com/office/2006/documentManagement/types"/>
+    <xsd:import namespace="http://schemas.microsoft.com/office/infopath/2007/PartnerControls"/>
+    <xsd:element name="SharedWithUsers" ma:index="11" nillable="true" ma:displayName="Shared With" ma:internalName="SharedWithUsers" ma:readOnly="true">
+      <xsd:complexType>
+        <xsd:complexContent>
+          <xsd:extension base="dms:UserMulti">
+            <xsd:sequence>
+              <xsd:element name="UserInfo" minOccurs="0" maxOccurs="unbounded">
+                <xsd:complexType>
+                  <xsd:sequence>
+                    <xsd:element name="DisplayName" type="xsd:string" minOccurs="0"/>
+                    <xsd:element name="AccountId" type="dms:UserId" minOccurs="0" nillable="true"/>
+                    <xsd:element name="AccountType" type="xsd:string" minOccurs="0"/>
+                  </xsd:sequence>
+                </xsd:complexType>
+              </xsd:element>
+            </xsd:sequence>
+          </xsd:extension>
+        </xsd:complexContent>
+      </xsd:complexType>
+    </xsd:element>
+    <xsd:element name="SharedWithDetails" ma:index="12" nillable="true" ma:displayName="Shared With Details" ma:internalName="SharedWithDetails" ma:readOnly="true">
+      <xsd:simpleType>
+        <xsd:restriction base="dms:Note">
+          <xsd:maxLength value="255"/>
+        </xsd:restriction>
+      </xsd:simpleType>
+    </xsd:element>
+    <xsd:element name="SharingHintHash" ma:index="13" nillable="true" ma:displayName="Sharing Hint Hash" ma:hidden="true" ma:internalName="SharingHintHash" ma:readOnly="true">
+      <xsd:simpleType>
+        <xsd:restriction base="dms:Text"/>
+      </xsd:simpleType>
+    </xsd:element>
+  </xsd:schema>
+  <xsd:schema xmlns="http://schemas.openxmlformats.org/package/2006/metadata/core-properties" xmlns:xsd="http://www.w3.org/2001/XMLSchema" xmlns:xsi="http://www.w3.org/2001/XMLSchema-instance" xmlns:dc="http://purl.org/dc/elements/1.1/" xmlns:dcterms="http://purl.org/dc/terms/" xmlns:odoc="http://schemas.microsoft.com/internal/obd" targetNamespace="http://schemas.openxmlformats.org/package/2006/metadata/core-properties" elementFormDefault="qualified" attributeFormDefault="unqualified" blockDefault="#all">
+    <xsd:import namespace="http://purl.org/dc/elements/1.1/" schemaLocation="http://dublincore.org/schemas/xmls/qdc/2003/04/02/dc.xsd"/>
+    <xsd:import namespace="http://purl.org/dc/terms/" schemaLocation="http://dublincore.org/schemas/xmls/qdc/2003/04/02/dcterms.xsd"/>
+    <xsd:element name="coreProperties" type="CT_coreProperties"/>
+    <xsd:complexType name="CT_coreProperties">
+      <xsd:all>
+        <xsd:element ref="dc:creator" minOccurs="0" maxOccurs="1"/>
+        <xsd:element ref="dcterms:created" minOccurs="0" maxOccurs="1"/>
+        <xsd:element ref="dc:identifier" minOccurs="0" maxOccurs="1"/>
+        <xsd:element name="contentType" minOccurs="0" maxOccurs="1" type="xsd:string" ma:index="0" ma:displayName="Content Type"/>
+        <xsd:element ref="dc:title" minOccurs="0" maxOccurs="1" ma:index="4" ma:displayName="Title"/>
+        <xsd:element ref="dc:subject" minOccurs="0" maxOccurs="1"/>
+        <xsd:element ref="dc:description" minOccurs="0" maxOccurs="1"/>
+        <xsd:element name="keywords" minOccurs="0" maxOccurs="1" type="xsd:string"/>
+        <xsd:element ref="dc:language" minOccurs="0" maxOccurs="1"/>
+        <xsd:element name="category" minOccurs="0" maxOccurs="1" type="xsd:string"/>
+        <xsd:element name="version" minOccurs="0" maxOccurs="1" type="xsd:string"/>
+        <xsd:element name="revision" minOccurs="0" maxOccurs="1" type="xsd:string">
+          <xsd:annotation>
+            <xsd:documentation>
+                        This value indicates the number of saves or revisions. The application is responsible for updating this value after each revision.
+                    </xsd:documentation>
+          </xsd:annotation>
+        </xsd:element>
+        <xsd:element name="lastModifiedBy" minOccurs="0" maxOccurs="1" type="xsd:string"/>
+        <xsd:element ref="dcterms:modified" minOccurs="0" maxOccurs="1"/>
+        <xsd:element name="contentStatus" minOccurs="0" maxOccurs="1" type="xsd:string"/>
+      </xsd:all>
+    </xsd:complexType>
+  </xsd:schema>
+  <xs:schema xmlns:pc="http://schemas.microsoft.com/office/infopath/2007/PartnerControls" xmlns:xs="http://www.w3.org/2001/XMLSchema" targetNamespace="http://schemas.microsoft.com/office/infopath/2007/PartnerControls" elementFormDefault="qualified" attributeFormDefault="unqualified">
+    <xs:element name="Person">
+      <xs:complexType>
+        <xs:sequence>
+          <xs:element ref="pc:DisplayName" minOccurs="0"/>
+          <xs:element ref="pc:AccountId" minOccurs="0"/>
+          <xs:element ref="pc:AccountType" minOccurs="0"/>
+        </xs:sequence>
+      </xs:complexType>
+    </xs:element>
+    <xs:element name="DisplayName" type="xs:string"/>
+    <xs:element name="AccountId" type="xs:string"/>
+    <xs:element name="AccountType" type="xs:string"/>
+    <xs:element name="BDCAssociatedEntity">
+      <xs:complexType>
+        <xs:sequence>
+          <xs:element ref="pc:BDCEntity" minOccurs="0" maxOccurs="unbounded"/>
+        </xs:sequence>
+        <xs:attribute ref="pc:EntityNamespace"/>
+        <xs:attribute ref="pc:EntityName"/>
+        <xs:attribute ref="pc:SystemInstanceName"/>
+        <xs:attribute ref="pc:AssociationName"/>
+      </xs:complexType>
+    </xs:element>
+    <xs:attribute name="EntityNamespace" type="xs:string"/>
+    <xs:attribute name="EntityName" type="xs:string"/>
+    <xs:attribute name="SystemInstanceName" type="xs:string"/>
+    <xs:attribute name="AssociationName" type="xs:string"/>
+    <xs:element name="BDCEntity">
+      <xs:complexType>
+        <xs:sequence>
+          <xs:element ref="pc:EntityDisplayName" minOccurs="0"/>
+          <xs:element ref="pc:EntityInstanceReference" minOccurs="0"/>
+          <xs:element ref="pc:EntityId1" minOccurs="0"/>
+          <xs:element ref="pc:EntityId2" minOccurs="0"/>
+          <xs:element ref="pc:EntityId3" minOccurs="0"/>
+          <xs:element ref="pc:EntityId4" minOccurs="0"/>
+          <xs:element ref="pc:EntityId5" minOccurs="0"/>
+        </xs:sequence>
+      </xs:complexType>
+    </xs:element>
+    <xs:element name="EntityDisplayName" type="xs:string"/>
+    <xs:element name="EntityInstanceReference" type="xs:string"/>
+    <xs:element name="EntityId1" type="xs:string"/>
+    <xs:element name="EntityId2" type="xs:string"/>
+    <xs:element name="EntityId3" type="xs:string"/>
+    <xs:element name="EntityId4" type="xs:string"/>
+    <xs:element name="EntityId5" type="xs:string"/>
+    <xs:element name="Terms">
+      <xs:complexType>
+        <xs:sequence>
+          <xs:element ref="pc:TermInfo" minOccurs="0" maxOccurs="unbounded"/>
+        </xs:sequence>
+      </xs:complexType>
+    </xs:element>
+    <xs:element name="TermInfo">
+      <xs:complexType>
+        <xs:sequence>
+          <xs:element ref="pc:TermName" minOccurs="0"/>
+          <xs:element ref="pc:TermId" minOccurs="0"/>
+        </xs:sequence>
+      </xs:complexType>
+    </xs:element>
+    <xs:element name="TermName" type="xs:string"/>
+    <xs:element name="TermId" type="xs:string"/>
+  </xs:schema>
+</ct:contentTypeSchema>
+</file>
+
+<file path=customXml/item3.xml><?xml version="1.0" encoding="utf-8"?>
+<p:properties xmlns:p="http://schemas.microsoft.com/office/2006/metadata/properties" xmlns:xsi="http://www.w3.org/2001/XMLSchema-instance" xmlns:pc="http://schemas.microsoft.com/office/infopath/2007/PartnerControls">
+  <documentManagement>
+    <_activity xmlns="39687eec-9f0c-43bc-aa81-f41a7d22872d" xsi:nil="true"/>
+  </documentManagement>
+</p:properties>
+</file>
+
+<file path=customXml/itemProps1.xml><?xml version="1.0" encoding="utf-8"?>
+<ds:datastoreItem xmlns:ds="http://schemas.openxmlformats.org/officeDocument/2006/customXml" ds:itemID="{4CD6D3B7-172E-44AC-BFAA-DB50306F7DC3}">
+  <ds:schemaRefs>
+    <ds:schemaRef ds:uri="http://schemas.microsoft.com/sharepoint/v3/contenttype/forms"/>
+  </ds:schemaRefs>
+</ds:datastoreItem>
+</file>
+
+<file path=customXml/itemProps2.xml><?xml version="1.0" encoding="utf-8"?>
+<ds:datastoreItem xmlns:ds="http://schemas.openxmlformats.org/officeDocument/2006/customXml" ds:itemID="{CE494FB8-869E-4F89-88F3-DD5022C12A5A}">
+  <ds:schemaRefs>
+    <ds:schemaRef ds:uri="http://schemas.microsoft.com/office/2006/metadata/contentType"/>
+    <ds:schemaRef ds:uri="http://schemas.microsoft.com/office/2006/metadata/properties/metaAttributes"/>
+    <ds:schemaRef ds:uri="http://www.w3.org/2001/XMLSchema"/>
+    <ds:schemaRef ds:uri="http://schemas.microsoft.com/office/2006/metadata/properties"/>
+    <ds:schemaRef ds:uri="39687eec-9f0c-43bc-aa81-f41a7d22872d"/>
+    <ds:schemaRef ds:uri="e9ac9483-9538-4d01-9b68-bc5731453717"/>
+    <ds:schemaRef ds:uri="http://schemas.microsoft.com/office/2006/documentManagement/types"/>
+    <ds:schemaRef ds:uri="http://schemas.microsoft.com/office/infopath/2007/PartnerControls"/>
+    <ds:schemaRef ds:uri="http://schemas.openxmlformats.org/package/2006/metadata/core-properties"/>
+    <ds:schemaRef ds:uri="http://purl.org/dc/elements/1.1/"/>
+    <ds:schemaRef ds:uri="http://purl.org/dc/terms/"/>
+    <ds:schemaRef ds:uri="http://schemas.microsoft.com/internal/obd"/>
+  </ds:schemaRefs>
+</ds:datastoreItem>
+</file>
+
+<file path=customXml/itemProps3.xml><?xml version="1.0" encoding="utf-8"?>
+<ds:datastoreItem xmlns:ds="http://schemas.openxmlformats.org/officeDocument/2006/customXml" ds:itemID="{14D1B855-CBE0-4C6D-AAED-AB0DD0DFD68F}">
+  <ds:schemaRefs>
+    <ds:schemaRef ds:uri="http://schemas.microsoft.com/office/2006/metadata/properties"/>
+    <ds:schemaRef ds:uri="http://schemas.microsoft.com/office/infopath/2007/PartnerControls"/>
+    <ds:schemaRef ds:uri="39687eec-9f0c-43bc-aa81-f41a7d22872d"/>
+  </ds:schemaRefs>
+</ds:datastoreItem>
 </file>
</xml_diff>

<commit_message>
doc: adicioando impulso a apresentação
</commit_message>
<xml_diff>
--- a/Slides_Projeto_C13_1.pptx
+++ b/Slides_Projeto_C13_1.pptx
@@ -16,6 +16,7 @@
     <p:sldId id="257" r:id="rId13"/>
     <p:sldId id="258" r:id="rId14"/>
     <p:sldId id="259" r:id="rId15"/>
+    <p:sldId id="268" r:id="rId16"/>
   </p:sldIdLst>
   <p:sldSz cx="12192000" cy="6858000"/>
   <p:notesSz cx="6858000" cy="9144000"/>
@@ -7919,6 +7920,614 @@
 </p:sld>
 </file>
 
+<file path=ppt/slides/slide12.xml><?xml version="1.0" encoding="utf-8"?>
+<p:sld xmlns:a="http://schemas.openxmlformats.org/drawingml/2006/main" xmlns:r="http://schemas.openxmlformats.org/officeDocument/2006/relationships" xmlns:p="http://schemas.openxmlformats.org/presentationml/2006/main">
+  <p:cSld>
+    <p:spTree>
+      <p:nvGrpSpPr>
+        <p:cNvPr id="1" name=""/>
+        <p:cNvGrpSpPr/>
+        <p:nvPr/>
+      </p:nvGrpSpPr>
+      <p:grpSpPr>
+        <a:xfrm>
+          <a:off x="0" y="0"/>
+          <a:ext cx="0" cy="0"/>
+          <a:chOff x="0" y="0"/>
+          <a:chExt cx="0" cy="0"/>
+        </a:xfrm>
+      </p:grpSpPr>
+      <p:sp>
+        <p:nvSpPr>
+          <p:cNvPr id="2" name="TextBox 1"/>
+          <p:cNvSpPr txBox="1"/>
+          <p:nvPr/>
+        </p:nvSpPr>
+        <p:spPr>
+          <a:xfrm>
+            <a:off x="594360" y="320040"/>
+            <a:ext cx="10972800" cy="475488"/>
+          </a:xfrm>
+          <a:prstGeom prst="rect">
+            <a:avLst/>
+          </a:prstGeom>
+          <a:noFill/>
+        </p:spPr>
+        <p:txBody>
+          <a:bodyPr wrap="square" lIns="45720" tIns="36576" rIns="45720" bIns="36576" anchor="t">
+            <a:spAutoFit/>
+          </a:bodyPr>
+          <a:lstStyle/>
+          <a:p>
+            <a:pPr algn="l">
+              <a:defRPr sz="2700" b="1">
+                <a:solidFill>
+                  <a:srgbClr val="182B45"/>
+                </a:solidFill>
+                <a:latin typeface="Aptos"/>
+              </a:defRPr>
+            </a:pPr>
+            <a:r>
+              <a:rPr dirty="0"/>
+              <a:t>Extra: o PID rejeita um degrau de carga</a:t>
+            </a:r>
+          </a:p>
+        </p:txBody>
+      </p:sp>
+      <p:sp>
+        <p:nvSpPr>
+          <p:cNvPr id="3" name="Rectangle 2"/>
+          <p:cNvSpPr/>
+          <p:nvPr/>
+        </p:nvSpPr>
+        <p:spPr>
+          <a:xfrm>
+            <a:off x="621792" y="896112"/>
+            <a:ext cx="731520" cy="50292"/>
+          </a:xfrm>
+          <a:prstGeom prst="rect">
+            <a:avLst/>
+          </a:prstGeom>
+          <a:solidFill>
+            <a:srgbClr val="16847E"/>
+          </a:solidFill>
+          <a:ln>
+            <a:noFill/>
+          </a:ln>
+        </p:spPr>
+        <p:style>
+          <a:lnRef idx="1">
+            <a:schemeClr val="accent1"/>
+          </a:lnRef>
+          <a:fillRef idx="3">
+            <a:schemeClr val="accent1"/>
+          </a:fillRef>
+          <a:effectRef idx="2">
+            <a:schemeClr val="accent1"/>
+          </a:effectRef>
+          <a:fontRef idx="minor">
+            <a:schemeClr val="lt1"/>
+          </a:fontRef>
+        </p:style>
+        <p:txBody>
+          <a:bodyPr rtlCol="0" anchor="ctr"/>
+          <a:lstStyle/>
+          <a:p>
+            <a:pPr algn="ctr"/>
+            <a:endParaRPr/>
+          </a:p>
+        </p:txBody>
+      </p:sp>
+      <p:sp>
+        <p:nvSpPr>
+          <p:cNvPr id="4" name="TextBox 3"/>
+          <p:cNvSpPr txBox="1"/>
+          <p:nvPr/>
+        </p:nvSpPr>
+        <p:spPr>
+          <a:xfrm>
+            <a:off x="621792" y="1005840"/>
+            <a:ext cx="10881360" cy="274320"/>
+          </a:xfrm>
+          <a:prstGeom prst="rect">
+            <a:avLst/>
+          </a:prstGeom>
+          <a:noFill/>
+        </p:spPr>
+        <p:txBody>
+          <a:bodyPr wrap="square" lIns="45720" tIns="36576" rIns="45720" bIns="36576" anchor="t">
+            <a:spAutoFit/>
+          </a:bodyPr>
+          <a:lstStyle/>
+          <a:p>
+            <a:pPr algn="l">
+              <a:defRPr sz="1100" b="0">
+                <a:solidFill>
+                  <a:srgbClr val="5D6A78"/>
+                </a:solidFill>
+                <a:latin typeface="Aptos"/>
+              </a:defRPr>
+            </a:pPr>
+            <a:r>
+              <a:rPr dirty="0" err="1"/>
+              <a:t>Carga de 15% do acionamento aplicada em t = 100 s, com o motor em 1800 RPM (modelo do ajuste fino).</a:t>
+            </a:r>
+          </a:p>
+        </p:txBody>
+      </p:sp>
+      <p:sp>
+        <p:nvSpPr>
+          <p:cNvPr id="7" name="Rounded Rectangle 6"/>
+          <p:cNvSpPr/>
+          <p:nvPr/>
+        </p:nvSpPr>
+        <p:spPr>
+          <a:xfrm>
+            <a:off x="7452360" y="1554480"/>
+            <a:ext cx="3977639" cy="1097280"/>
+          </a:xfrm>
+          <a:prstGeom prst="roundRect">
+            <a:avLst/>
+          </a:prstGeom>
+          <a:solidFill>
+            <a:srgbClr val="F0F5F8"/>
+          </a:solidFill>
+          <a:ln>
+            <a:solidFill>
+              <a:srgbClr val="DCE5EB"/>
+            </a:solidFill>
+          </a:ln>
+        </p:spPr>
+        <p:style>
+          <a:lnRef idx="1">
+            <a:schemeClr val="accent1"/>
+          </a:lnRef>
+          <a:fillRef idx="3">
+            <a:schemeClr val="accent1"/>
+          </a:fillRef>
+          <a:effectRef idx="2">
+            <a:schemeClr val="accent1"/>
+          </a:effectRef>
+          <a:fontRef idx="minor">
+            <a:schemeClr val="lt1"/>
+          </a:fontRef>
+        </p:style>
+        <p:txBody>
+          <a:bodyPr rtlCol="0" anchor="ctr"/>
+          <a:lstStyle/>
+          <a:p>
+            <a:pPr algn="ctr"/>
+            <a:endParaRPr/>
+          </a:p>
+        </p:txBody>
+      </p:sp>
+      <p:sp>
+        <p:nvSpPr>
+          <p:cNvPr id="8" name="TextBox 7"/>
+          <p:cNvSpPr txBox="1"/>
+          <p:nvPr/>
+        </p:nvSpPr>
+        <p:spPr>
+          <a:xfrm>
+            <a:off x="7635240" y="1682495"/>
+            <a:ext cx="3611879" cy="289310"/>
+          </a:xfrm>
+          <a:prstGeom prst="rect">
+            <a:avLst/>
+          </a:prstGeom>
+          <a:noFill/>
+        </p:spPr>
+        <p:txBody>
+          <a:bodyPr wrap="square" lIns="45720" tIns="36576" rIns="45720" bIns="36576" anchor="t">
+            <a:spAutoFit/>
+          </a:bodyPr>
+          <a:lstStyle/>
+          <a:p>
+            <a:pPr algn="l">
+              <a:defRPr sz="1500" b="1">
+                <a:solidFill>
+                  <a:srgbClr val="16847E"/>
+                </a:solidFill>
+                <a:latin typeface="Aptos"/>
+              </a:defRPr>
+            </a:pPr>
+            <a:r>
+              <a:rPr sz="1400" dirty="0">
+                <a:latin typeface="Arial" panose="020B0604020202020204" pitchFamily="34" charset="0"/>
+                <a:cs typeface="Arial" panose="020B0604020202020204" pitchFamily="34" charset="0"/>
+              </a:rPr>
+              <a:t>Ziegler-Nichols</a:t>
+            </a:r>
+          </a:p>
+        </p:txBody>
+      </p:sp>
+      <p:sp>
+        <p:nvSpPr>
+          <p:cNvPr id="9" name="TextBox 8"/>
+          <p:cNvSpPr txBox="1"/>
+          <p:nvPr/>
+        </p:nvSpPr>
+        <p:spPr>
+          <a:xfrm>
+            <a:off x="7635240" y="1946776"/>
+            <a:ext cx="3611879" cy="735586"/>
+          </a:xfrm>
+          <a:prstGeom prst="rect">
+            <a:avLst/>
+          </a:prstGeom>
+          <a:noFill/>
+        </p:spPr>
+        <p:txBody>
+          <a:bodyPr wrap="square" lIns="45720" tIns="36576" rIns="45720" bIns="36576" anchor="t">
+            <a:spAutoFit/>
+          </a:bodyPr>
+          <a:lstStyle/>
+          <a:p>
+            <a:pPr>
+              <a:defRPr sz="1500" b="0">
+                <a:solidFill>
+                  <a:srgbClr val="2B343E"/>
+                </a:solidFill>
+                <a:latin typeface="Aptos"/>
+              </a:defRPr>
+            </a:pPr>
+            <a:r>
+              <a:rPr sz="1400" dirty="0">
+                <a:latin typeface="Arial" panose="020B0604020202020204" pitchFamily="34" charset="0"/>
+                <a:cs typeface="Arial" panose="020B0604020202020204" pitchFamily="34" charset="0"/>
+              </a:rPr>
+              <a:t>Queda máxima: 42 RPM</a:t>
+            </a:r>
+            <a:br/>
+            <a:r>
+              <a:rPr sz="1400" dirty="0">
+                <a:latin typeface="Arial" panose="020B0604020202020204" pitchFamily="34" charset="0"/>
+                <a:cs typeface="Arial" panose="020B0604020202020204" pitchFamily="34" charset="0"/>
+              </a:rPr>
+              <a:t>Volta à faixa de 2%: 6,81 s</a:t>
+            </a:r>
+            <a:br/>
+            <a:r>
+              <a:rPr sz="1400" dirty="0">
+                <a:latin typeface="Arial" panose="020B0604020202020204" pitchFamily="34" charset="0"/>
+                <a:cs typeface="Arial" panose="020B0604020202020204" pitchFamily="34" charset="0"/>
+              </a:rPr>
+              <a:t>Erro final: 0</a:t>
+            </a:r>
+          </a:p>
+        </p:txBody>
+      </p:sp>
+      <p:sp>
+        <p:nvSpPr>
+          <p:cNvPr id="10" name="Rounded Rectangle 9"/>
+          <p:cNvSpPr/>
+          <p:nvPr/>
+        </p:nvSpPr>
+        <p:spPr>
+          <a:xfrm>
+            <a:off x="7452360" y="2834640"/>
+            <a:ext cx="3977639" cy="1097280"/>
+          </a:xfrm>
+          <a:prstGeom prst="roundRect">
+            <a:avLst/>
+          </a:prstGeom>
+          <a:solidFill>
+            <a:srgbClr val="F0F5F8"/>
+          </a:solidFill>
+          <a:ln>
+            <a:solidFill>
+              <a:srgbClr val="DCE5EB"/>
+            </a:solidFill>
+          </a:ln>
+        </p:spPr>
+        <p:style>
+          <a:lnRef idx="1">
+            <a:schemeClr val="accent1"/>
+          </a:lnRef>
+          <a:fillRef idx="3">
+            <a:schemeClr val="accent1"/>
+          </a:fillRef>
+          <a:effectRef idx="2">
+            <a:schemeClr val="accent1"/>
+          </a:effectRef>
+          <a:fontRef idx="minor">
+            <a:schemeClr val="lt1"/>
+          </a:fontRef>
+        </p:style>
+        <p:txBody>
+          <a:bodyPr rtlCol="0" anchor="ctr"/>
+          <a:lstStyle/>
+          <a:p>
+            <a:pPr algn="ctr"/>
+            <a:endParaRPr/>
+          </a:p>
+        </p:txBody>
+      </p:sp>
+      <p:sp>
+        <p:nvSpPr>
+          <p:cNvPr id="11" name="TextBox 10"/>
+          <p:cNvSpPr txBox="1"/>
+          <p:nvPr/>
+        </p:nvSpPr>
+        <p:spPr>
+          <a:xfrm>
+            <a:off x="7635240" y="2962656"/>
+            <a:ext cx="3611879" cy="289310"/>
+          </a:xfrm>
+          <a:prstGeom prst="rect">
+            <a:avLst/>
+          </a:prstGeom>
+          <a:noFill/>
+        </p:spPr>
+        <p:txBody>
+          <a:bodyPr wrap="square" lIns="45720" tIns="36576" rIns="45720" bIns="36576" anchor="t">
+            <a:spAutoFit/>
+          </a:bodyPr>
+          <a:lstStyle/>
+          <a:p>
+            <a:pPr algn="l">
+              <a:defRPr sz="1500" b="1">
+                <a:solidFill>
+                  <a:srgbClr val="2F69A4"/>
+                </a:solidFill>
+                <a:latin typeface="Aptos"/>
+              </a:defRPr>
+            </a:pPr>
+            <a:r>
+              <a:rPr sz="1400" dirty="0">
+                <a:latin typeface="Arial" panose="020B0604020202020204" pitchFamily="34" charset="0"/>
+                <a:cs typeface="Arial" panose="020B0604020202020204" pitchFamily="34" charset="0"/>
+              </a:rPr>
+              <a:t>Cohen-Coon</a:t>
+            </a:r>
+          </a:p>
+        </p:txBody>
+      </p:sp>
+      <p:sp>
+        <p:nvSpPr>
+          <p:cNvPr id="12" name="TextBox 11"/>
+          <p:cNvSpPr txBox="1"/>
+          <p:nvPr/>
+        </p:nvSpPr>
+        <p:spPr>
+          <a:xfrm>
+            <a:off x="7635239" y="3195829"/>
+            <a:ext cx="3611879" cy="720197"/>
+          </a:xfrm>
+          <a:prstGeom prst="rect">
+            <a:avLst/>
+          </a:prstGeom>
+          <a:noFill/>
+        </p:spPr>
+        <p:txBody>
+          <a:bodyPr wrap="square" lIns="45720" tIns="36576" rIns="45720" bIns="36576" anchor="t">
+            <a:spAutoFit/>
+          </a:bodyPr>
+          <a:lstStyle/>
+          <a:p>
+            <a:pPr algn="l">
+              <a:defRPr sz="1500" b="0">
+                <a:solidFill>
+                  <a:srgbClr val="2B343E"/>
+                </a:solidFill>
+                <a:latin typeface="Aptos"/>
+              </a:defRPr>
+            </a:pPr>
+            <a:r>
+              <a:rPr sz="1400" dirty="0">
+                <a:latin typeface="Arial" panose="020B0604020202020204" pitchFamily="34" charset="0"/>
+                <a:cs typeface="Arial" panose="020B0604020202020204" pitchFamily="34" charset="0"/>
+              </a:rPr>
+              <a:t>Queda máxima: 43 RPM</a:t>
+            </a:r>
+            <a:br/>
+            <a:r>
+              <a:rPr sz="1400" dirty="0">
+                <a:latin typeface="Arial" panose="020B0604020202020204" pitchFamily="34" charset="0"/>
+                <a:cs typeface="Arial" panose="020B0604020202020204" pitchFamily="34" charset="0"/>
+              </a:rPr>
+              <a:t>Volta à faixa de 2%: 6,94 s</a:t>
+            </a:r>
+            <a:br/>
+            <a:r>
+              <a:rPr sz="1400" dirty="0">
+                <a:latin typeface="Arial" panose="020B0604020202020204" pitchFamily="34" charset="0"/>
+                <a:cs typeface="Arial" panose="020B0604020202020204" pitchFamily="34" charset="0"/>
+              </a:rPr>
+              <a:t>Erro final: 0</a:t>
+            </a:r>
+          </a:p>
+        </p:txBody>
+      </p:sp>
+      <p:sp>
+        <p:nvSpPr>
+          <p:cNvPr id="13" name="Rounded Rectangle 12"/>
+          <p:cNvSpPr/>
+          <p:nvPr/>
+        </p:nvSpPr>
+        <p:spPr>
+          <a:xfrm>
+            <a:off x="7452360" y="4160520"/>
+            <a:ext cx="3977639" cy="1965960"/>
+          </a:xfrm>
+          <a:prstGeom prst="roundRect">
+            <a:avLst/>
+          </a:prstGeom>
+          <a:solidFill>
+            <a:srgbClr val="F0F5F8"/>
+          </a:solidFill>
+          <a:ln>
+            <a:solidFill>
+              <a:srgbClr val="DCE5EB"/>
+            </a:solidFill>
+          </a:ln>
+        </p:spPr>
+        <p:style>
+          <a:lnRef idx="1">
+            <a:schemeClr val="accent1"/>
+          </a:lnRef>
+          <a:fillRef idx="3">
+            <a:schemeClr val="accent1"/>
+          </a:fillRef>
+          <a:effectRef idx="2">
+            <a:schemeClr val="accent1"/>
+          </a:effectRef>
+          <a:fontRef idx="minor">
+            <a:schemeClr val="lt1"/>
+          </a:fontRef>
+        </p:style>
+        <p:txBody>
+          <a:bodyPr rtlCol="0" anchor="ctr"/>
+          <a:lstStyle/>
+          <a:p>
+            <a:pPr algn="ctr"/>
+            <a:endParaRPr/>
+          </a:p>
+        </p:txBody>
+      </p:sp>
+      <p:sp>
+        <p:nvSpPr>
+          <p:cNvPr id="14" name="TextBox 13"/>
+          <p:cNvSpPr txBox="1"/>
+          <p:nvPr/>
+        </p:nvSpPr>
+        <p:spPr>
+          <a:xfrm>
+            <a:off x="7658100" y="4151375"/>
+            <a:ext cx="3611879" cy="289310"/>
+          </a:xfrm>
+          <a:prstGeom prst="rect">
+            <a:avLst/>
+          </a:prstGeom>
+          <a:noFill/>
+        </p:spPr>
+        <p:txBody>
+          <a:bodyPr wrap="square" lIns="45720" tIns="36576" rIns="45720" bIns="36576" anchor="t">
+            <a:spAutoFit/>
+          </a:bodyPr>
+          <a:lstStyle/>
+          <a:p>
+            <a:pPr algn="l">
+              <a:defRPr sz="1500" b="1">
+                <a:solidFill>
+                  <a:srgbClr val="CD7731"/>
+                </a:solidFill>
+                <a:latin typeface="Aptos"/>
+              </a:defRPr>
+            </a:pPr>
+            <a:r>
+              <a:rPr sz="1400" dirty="0" err="1">
+                <a:latin typeface="Arial" panose="020B0604020202020204" pitchFamily="34" charset="0"/>
+                <a:cs typeface="Arial" panose="020B0604020202020204" pitchFamily="34" charset="0"/>
+              </a:rPr>
+              <a:t>Conclusão</a:t>
+            </a:r>
+            <a:endParaRPr sz="1400" dirty="0">
+              <a:latin typeface="Arial" panose="020B0604020202020204" pitchFamily="34" charset="0"/>
+              <a:cs typeface="Arial" panose="020B0604020202020204" pitchFamily="34" charset="0"/>
+            </a:endParaRPr>
+          </a:p>
+        </p:txBody>
+      </p:sp>
+      <p:sp>
+        <p:nvSpPr>
+          <p:cNvPr id="15" name="TextBox 14"/>
+          <p:cNvSpPr txBox="1"/>
+          <p:nvPr/>
+        </p:nvSpPr>
+        <p:spPr>
+          <a:xfrm>
+            <a:off x="7635238" y="4446037"/>
+            <a:ext cx="3611879" cy="1797415"/>
+          </a:xfrm>
+          <a:prstGeom prst="rect">
+            <a:avLst/>
+          </a:prstGeom>
+          <a:noFill/>
+        </p:spPr>
+        <p:txBody>
+          <a:bodyPr wrap="square" lIns="45720" tIns="36576" rIns="45720" bIns="36576" anchor="t">
+            <a:spAutoFit/>
+          </a:bodyPr>
+          <a:lstStyle/>
+          <a:p>
+            <a:pPr marL="285750" indent="-285750">
+              <a:buFont typeface="Arial" panose="020B0604020202020204" pitchFamily="34" charset="0"/>
+              <a:buChar char="•"/>
+              <a:defRPr sz="1400" b="0">
+                <a:solidFill>
+                  <a:srgbClr val="2B343E"/>
+                </a:solidFill>
+                <a:latin typeface="Aptos"/>
+              </a:defRPr>
+            </a:pPr>
+            <a:r>
+              <a:rPr lang="pt-BR" sz="1400" dirty="0">
+                <a:solidFill>
+                  <a:srgbClr val="2B343E"/>
+                </a:solidFill>
+                <a:latin typeface="Arial" panose="020B0604020202020204" pitchFamily="34" charset="0"/>
+                <a:cs typeface="Arial" panose="020B0604020202020204" pitchFamily="34" charset="0"/>
+              </a:rPr>
+              <a:t>Sem controle, a carga derruba a velocidade em 337,5 RPM, de forma permanente.</a:t>
+            </a:r>
+          </a:p>
+          <a:p>
+            <a:pPr marL="285750" indent="-285750">
+              <a:buFont typeface="Arial" panose="020B0604020202020204" pitchFamily="34" charset="0"/>
+              <a:buChar char="•"/>
+              <a:defRPr sz="1400" b="0">
+                <a:solidFill>
+                  <a:srgbClr val="2B343E"/>
+                </a:solidFill>
+                <a:latin typeface="Aptos"/>
+              </a:defRPr>
+            </a:pPr>
+            <a:r>
+              <a:rPr lang="pt-BR" sz="1400" dirty="0">
+                <a:solidFill>
+                  <a:srgbClr val="2B343E"/>
+                </a:solidFill>
+                <a:latin typeface="Arial" panose="020B0604020202020204" pitchFamily="34" charset="0"/>
+                <a:cs typeface="Arial" panose="020B0604020202020204" pitchFamily="34" charset="0"/>
+              </a:rPr>
+              <a:t>Com PID, a queda é 8 vezes menor e a ação integral traz o motor de volta ao SetPoint.</a:t>
+            </a:r>
+          </a:p>
+        </p:txBody>
+      </p:sp>
+      <p:pic>
+        <p:nvPicPr>
+          <p:cNvPr id="16" name="Picture 15" descr="degrau_carga.png"/>
+          <p:cNvPicPr>
+            <a:picLocks noChangeAspect="1"/>
+          </p:cNvPicPr>
+          <p:nvPr/>
+        </p:nvPicPr>
+        <p:blipFill>
+          <a:blip r:embed="rId2"/>
+          <a:stretch>
+            <a:fillRect/>
+          </a:stretch>
+        </p:blipFill>
+        <p:spPr>
+          <a:xfrm>
+            <a:off x="548640" y="2476500"/>
+            <a:ext cx="6766560" cy="2819400"/>
+          </a:xfrm>
+          <a:prstGeom prst="rect">
+            <a:avLst/>
+          </a:prstGeom>
+        </p:spPr>
+      </p:pic>
+    </p:spTree>
+  </p:cSld>
+  <p:clrMapOvr>
+    <a:masterClrMapping/>
+  </p:clrMapOvr>
+</p:sld>
+</file>
+
 <file path=ppt/slides/slide2.xml><?xml version="1.0" encoding="utf-8"?>
 <p:sld xmlns:a="http://schemas.openxmlformats.org/drawingml/2006/main" xmlns:r="http://schemas.openxmlformats.org/officeDocument/2006/relationships" xmlns:p="http://schemas.openxmlformats.org/presentationml/2006/main">
   <p:cSld>
@@ -8506,7 +9115,7 @@
                 </a:solidFill>
                 <a:latin typeface="Arial"/>
               </a:rPr>
-              <a:t>Interface</a:t>
+              <a:t>Extra e interface</a:t>
             </a:r>
           </a:p>
           <a:p>
@@ -8517,7 +9126,7 @@
                 </a:solidFill>
                 <a:latin typeface="Arial"/>
               </a:rPr>
-              <a:t>Demonstração ao vivo</a:t>
+              <a:t>Degrau de carga e demonstração ao vivo</a:t>
             </a:r>
           </a:p>
         </p:txBody>
@@ -8555,36 +9164,6 @@
           <a:chExt cx="0" cy="0"/>
         </a:xfrm>
       </p:grpSpPr>
-      <p:pic>
-        <p:nvPicPr>
-          <p:cNvPr id="14" name="Imagem 13">
-            <a:extLst>
-              <a:ext uri="{FF2B5EF4-FFF2-40B4-BE49-F238E27FC236}">
-                <a16:creationId xmlns:a16="http://schemas.microsoft.com/office/drawing/2014/main" id="{70400D51-F05B-85CB-3685-78A1AF503B3E}"/>
-              </a:ext>
-            </a:extLst>
-          </p:cNvPr>
-          <p:cNvPicPr>
-            <a:picLocks noChangeAspect="1"/>
-          </p:cNvPicPr>
-          <p:nvPr/>
-        </p:nvPicPr>
-        <p:blipFill>
-          <a:blip r:embed="rId2"/>
-          <a:stretch>
-            <a:fillRect/>
-          </a:stretch>
-        </p:blipFill>
-        <p:spPr>
-          <a:xfrm>
-            <a:off x="594360" y="1250320"/>
-            <a:ext cx="8139562" cy="3216326"/>
-          </a:xfrm>
-          <a:prstGeom prst="rect">
-            <a:avLst/>
-          </a:prstGeom>
-        </p:spPr>
-      </p:pic>
       <p:sp>
         <p:nvSpPr>
           <p:cNvPr id="2" name="TextBox 1"/>
@@ -8895,6 +9474,30 @@
           </p:txBody>
         </p:sp>
       </p:grpSp>
+      <p:pic>
+        <p:nvPicPr>
+          <p:cNvPr id="9" name="Circuito equivalente" descr="circuito_motor.png"/>
+          <p:cNvPicPr>
+            <a:picLocks noChangeAspect="1"/>
+          </p:cNvPicPr>
+          <p:nvPr/>
+        </p:nvPicPr>
+        <p:blipFill>
+          <a:blip r:embed="rId2"/>
+          <a:stretch>
+            <a:fillRect/>
+          </a:stretch>
+        </p:blipFill>
+        <p:spPr>
+          <a:xfrm>
+            <a:off x="594360" y="1371600"/>
+            <a:ext cx="8138160" cy="2693855"/>
+          </a:xfrm>
+          <a:prstGeom prst="rect">
+            <a:avLst/>
+          </a:prstGeom>
+        </p:spPr>
+      </p:pic>
     </p:spTree>
   </p:cSld>
   <p:clrMapOvr>
@@ -9830,7 +10433,7 @@
         <p:spPr>
           <a:xfrm>
             <a:off x="731520" y="1325713"/>
-            <a:ext cx="5257800" cy="2132380"/>
+            <a:ext cx="5257800" cy="1965960"/>
           </a:xfrm>
           <a:prstGeom prst="roundRect">
             <a:avLst/>
@@ -10030,7 +10633,7 @@
         <p:spPr>
           <a:xfrm>
             <a:off x="6126479" y="1280160"/>
-            <a:ext cx="5248469" cy="2148840"/>
+            <a:ext cx="5248469" cy="1965960"/>
           </a:xfrm>
           <a:prstGeom prst="roundRect">
             <a:avLst/>
@@ -10251,8 +10854,8 @@
         </p:nvSpPr>
         <p:spPr>
           <a:xfrm>
-            <a:off x="731520" y="3790868"/>
-            <a:ext cx="5148070" cy="2151047"/>
+            <a:off x="731520" y="3474720"/>
+            <a:ext cx="5148070" cy="2468880"/>
           </a:xfrm>
           <a:prstGeom prst="roundRect">
             <a:avLst/>
@@ -10281,7 +10884,7 @@
           </a:fontRef>
         </p:style>
         <p:txBody>
-          <a:bodyPr rtlCol="0" anchor="ctr"/>
+          <a:bodyPr lIns="228600" tIns="493776" rIns="182880" rtlCol="0" anchor="t"/>
           <a:lstStyle/>
           <a:p>
             <a:pPr marL="285750" indent="-285750">
@@ -10296,7 +10899,7 @@
                 <a:latin typeface="Arial" panose="020B0604020202020204" pitchFamily="34" charset="0"/>
                 <a:cs typeface="Arial" panose="020B0604020202020204" pitchFamily="34" charset="0"/>
               </a:rPr>
-              <a:t>Carga mecânica: o aumento da carga no eixo pode reduzir a rotação.</a:t>
+              <a:t>Carga mecânica (0 a 20% do acionamento): sem controle, derruba até ≈ 450 RPM.</a:t>
             </a:r>
           </a:p>
           <a:p>
@@ -10312,7 +10915,7 @@
                 <a:latin typeface="Arial" panose="020B0604020202020204" pitchFamily="34" charset="0"/>
                 <a:cs typeface="Arial" panose="020B0604020202020204" pitchFamily="34" charset="0"/>
               </a:rPr>
-              <a:t>Alimentação elétrica: variações na tensão podem alterar o desempenho do motor.</a:t>
+              <a:t>Tensão de alimentação (±10%): ≈ ±180 RPM sem controle.</a:t>
             </a:r>
           </a:p>
           <a:p>
@@ -10328,15 +10931,24 @@
                 <a:latin typeface="Arial" panose="020B0604020202020204" pitchFamily="34" charset="0"/>
                 <a:cs typeface="Arial" panose="020B0604020202020204" pitchFamily="34" charset="0"/>
               </a:rPr>
-              <a:t>Atrito e aquecimento: modificam as condições de funcionamento e podem afetar a velocidade.</a:t>
-            </a:r>
-            <a:endParaRPr sz="1400" dirty="0">
-              <a:solidFill>
-                <a:schemeClr val="tx1"/>
-              </a:solidFill>
-              <a:latin typeface="Arial" panose="020B0604020202020204" pitchFamily="34" charset="0"/>
-              <a:cs typeface="Arial" panose="020B0604020202020204" pitchFamily="34" charset="0"/>
-            </a:endParaRPr>
+              <a:t>Aquecimento (Ra até ≈ +20%) e atrito: mudam as perdas e a velocidade.</a:t>
+            </a:r>
+          </a:p>
+          <a:p>
+            <a:pPr marL="285750" indent="-285750">
+              <a:buFont typeface="Arial" panose="020B0604020202020204" pitchFamily="34" charset="0"/>
+              <a:buChar char="•"/>
+            </a:pPr>
+            <a:r>
+              <a:rPr lang="pt-BR" sz="1400" dirty="0">
+                <a:solidFill>
+                  <a:schemeClr val="tx1"/>
+                </a:solidFill>
+                <a:latin typeface="Arial" panose="020B0604020202020204" pitchFamily="34" charset="0"/>
+                <a:cs typeface="Arial" panose="020B0604020202020204" pitchFamily="34" charset="0"/>
+              </a:rPr>
+              <a:t>Ruído de medição: desvio de ≈ 10 RPM.</a:t>
+            </a:r>
           </a:p>
         </p:txBody>
       </p:sp>
@@ -10354,7 +10966,7 @@
         </p:nvSpPr>
         <p:spPr>
           <a:xfrm>
-            <a:off x="1033270" y="3887861"/>
+            <a:off x="1033270" y="3571713"/>
             <a:ext cx="4846320" cy="289310"/>
           </a:xfrm>
           <a:prstGeom prst="rect">
@@ -10404,8 +11016,8 @@
         </p:nvSpPr>
         <p:spPr>
           <a:xfrm>
-            <a:off x="6135808" y="3790867"/>
-            <a:ext cx="5248470" cy="2151047"/>
+            <a:off x="6135808" y="3474719"/>
+            <a:ext cx="5248470" cy="2468880"/>
           </a:xfrm>
           <a:prstGeom prst="roundRect">
             <a:avLst/>
@@ -10456,7 +11068,7 @@
         </p:nvSpPr>
         <p:spPr>
           <a:xfrm>
-            <a:off x="6431280" y="3842058"/>
+            <a:off x="6431280" y="3525910"/>
             <a:ext cx="4846320" cy="289310"/>
           </a:xfrm>
           <a:prstGeom prst="rect">
@@ -10520,7 +11132,7 @@
         </p:nvSpPr>
         <p:spPr>
           <a:xfrm>
-            <a:off x="6355080" y="4233613"/>
+            <a:off x="6355080" y="3917465"/>
             <a:ext cx="4846320" cy="1397306"/>
           </a:xfrm>
           <a:prstGeom prst="rect">
@@ -10601,7 +11213,7 @@
         </p:nvSpPr>
         <p:spPr>
           <a:xfrm>
-            <a:off x="859349" y="6044160"/>
+            <a:off x="859349" y="6080760"/>
             <a:ext cx="10515600" cy="289310"/>
           </a:xfrm>
           <a:prstGeom prst="rect">

</xml_diff>